<commit_message>
Remove signature image and Office lock file from the repository
</commit_message>
<xml_diff>
--- a/docs/deck/Cap2_SBOM_Risk_Engine_results.pptx
+++ b/docs/deck/Cap2_SBOM_Risk_Engine_results.pptx
@@ -199,13 +199,13 @@
               <c:strCache>
                 <c:ptCount val="10"/>
                 <c:pt idx="0">
-                  <c:v>References tagged Exploit</c:v>
+                  <c:v>Other CWE</c:v>
                 </c:pt>
                 <c:pt idx="1">
                   <c:v>CWE-79</c:v>
                 </c:pt>
                 <c:pt idx="2">
-                  <c:v>Other CWE</c:v>
+                  <c:v>References tagged Exploit</c:v>
                 </c:pt>
                 <c:pt idx="3">
                   <c:v>Description length</c:v>
@@ -214,10 +214,10 @@
                   <c:v>GitHub reference</c:v>
                 </c:pt>
                 <c:pt idx="5">
+                  <c:v>Number of references</c:v>
+                </c:pt>
+                <c:pt idx="6">
                   <c:v>Vendor's historical KEV rate</c:v>
-                </c:pt>
-                <c:pt idx="6">
-                  <c:v>Number of references</c:v>
                 </c:pt>
                 <c:pt idx="7">
                   <c:v>Vendor advisories</c:v>
@@ -238,34 +238,34 @@
                 <c:formatCode>General</c:formatCode>
                 <c:ptCount val="10"/>
                 <c:pt idx="0">
-                  <c:v>0.2033</c:v>
+                  <c:v>0.2087</c:v>
                 </c:pt>
                 <c:pt idx="1">
-                  <c:v>0.2129</c:v>
+                  <c:v>0.2125</c:v>
                 </c:pt>
                 <c:pt idx="2">
-                  <c:v>0.2131</c:v>
+                  <c:v>0.2137</c:v>
                 </c:pt>
                 <c:pt idx="3">
-                  <c:v>0.2474</c:v>
+                  <c:v>0.2447</c:v>
                 </c:pt>
                 <c:pt idx="4">
-                  <c:v>0.3156</c:v>
+                  <c:v>0.3288</c:v>
                 </c:pt>
                 <c:pt idx="5">
-                  <c:v>0.3531</c:v>
+                  <c:v>0.3461</c:v>
                 </c:pt>
                 <c:pt idx="6">
-                  <c:v>0.3572</c:v>
+                  <c:v>0.3536</c:v>
                 </c:pt>
                 <c:pt idx="7">
-                  <c:v>0.4447</c:v>
+                  <c:v>0.4238</c:v>
                 </c:pt>
                 <c:pt idx="8">
-                  <c:v>0.5921</c:v>
+                  <c:v>0.5904</c:v>
                 </c:pt>
                 <c:pt idx="9">
-                  <c:v>0.6079</c:v>
+                  <c:v>0.6202</c:v>
                 </c:pt>
               </c:numCache>
             </c:numRef>
@@ -351,7 +351,7 @@
           <a:p>
             <a:r>
               <a:rPr sz="1100" b="1"/>
-              <a:t>Coverage curve, frozen 2025-01-01: legacy-java-app</a:t>
+              <a:t>Coverage curve, frozen 2024-01-01: kev-app</a:t>
             </a:r>
           </a:p>
         </c:rich>
@@ -363,6 +363,2198 @@
       <c:scatterChart>
         <c:scatterStyle val="lineMarker"/>
         <c:varyColors val="0"/>
+        <c:ser>
+          <c:idx val="0"/>
+          <c:order val="0"/>
+          <c:tx>
+            <c:strRef>
+              <c:f>Sheet1!$B$1</c:f>
+              <c:strCache>
+                <c:ptCount val="1"/>
+                <c:pt idx="0">
+                  <c:v>CVSS-only</c:v>
+                </c:pt>
+              </c:strCache>
+            </c:strRef>
+          </c:tx>
+          <c:spPr>
+            <a:ln w="19050">
+              <a:solidFill>
+                <a:srgbClr val="D63B40"/>
+              </a:solidFill>
+            </a:ln>
+          </c:spPr>
+          <c:marker>
+            <c:symbol val="none"/>
+          </c:marker>
+          <c:xVal>
+            <c:numRef>
+              <c:f>Sheet1!$A$2:$A$27</c:f>
+              <c:numCache>
+                <c:formatCode>General</c:formatCode>
+                <c:ptCount val="26"/>
+                <c:pt idx="0">
+                  <c:v>0.0</c:v>
+                </c:pt>
+                <c:pt idx="1">
+                  <c:v>0.06</c:v>
+                </c:pt>
+                <c:pt idx="2">
+                  <c:v>0.0667</c:v>
+                </c:pt>
+                <c:pt idx="3">
+                  <c:v>0.0933</c:v>
+                </c:pt>
+                <c:pt idx="4">
+                  <c:v>0.16</c:v>
+                </c:pt>
+                <c:pt idx="5">
+                  <c:v>0.1667</c:v>
+                </c:pt>
+                <c:pt idx="6">
+                  <c:v>0.1733</c:v>
+                </c:pt>
+                <c:pt idx="7">
+                  <c:v>0.2067</c:v>
+                </c:pt>
+                <c:pt idx="8">
+                  <c:v>0.2267</c:v>
+                </c:pt>
+                <c:pt idx="9">
+                  <c:v>0.2333</c:v>
+                </c:pt>
+                <c:pt idx="10">
+                  <c:v>0.3067</c:v>
+                </c:pt>
+                <c:pt idx="11">
+                  <c:v>0.3133</c:v>
+                </c:pt>
+                <c:pt idx="12">
+                  <c:v>0.3267</c:v>
+                </c:pt>
+                <c:pt idx="13">
+                  <c:v>0.3333</c:v>
+                </c:pt>
+                <c:pt idx="14">
+                  <c:v>0.34</c:v>
+                </c:pt>
+                <c:pt idx="15">
+                  <c:v>0.46</c:v>
+                </c:pt>
+                <c:pt idx="16">
+                  <c:v>0.4867</c:v>
+                </c:pt>
+                <c:pt idx="17">
+                  <c:v>0.4933</c:v>
+                </c:pt>
+                <c:pt idx="18">
+                  <c:v>0.5</c:v>
+                </c:pt>
+                <c:pt idx="19">
+                  <c:v>0.7067</c:v>
+                </c:pt>
+                <c:pt idx="20">
+                  <c:v>0.7667</c:v>
+                </c:pt>
+                <c:pt idx="21">
+                  <c:v>0.7867</c:v>
+                </c:pt>
+                <c:pt idx="22">
+                  <c:v>0.7933</c:v>
+                </c:pt>
+                <c:pt idx="23">
+                  <c:v>0.8</c:v>
+                </c:pt>
+                <c:pt idx="24">
+                  <c:v>0.9933</c:v>
+                </c:pt>
+                <c:pt idx="25">
+                  <c:v>1.0</c:v>
+                </c:pt>
+              </c:numCache>
+            </c:numRef>
+          </c:xVal>
+          <c:yVal>
+            <c:numRef>
+              <c:f>Sheet1!$B$2:$B$27</c:f>
+              <c:numCache>
+                <c:formatCode>General</c:formatCode>
+                <c:ptCount val="26"/>
+                <c:pt idx="0">
+                  <c:v>0.0</c:v>
+                </c:pt>
+                <c:pt idx="1">
+                  <c:v>0.5</c:v>
+                </c:pt>
+                <c:pt idx="2">
+                  <c:v>0.5</c:v>
+                </c:pt>
+                <c:pt idx="3">
+                  <c:v>0.5</c:v>
+                </c:pt>
+                <c:pt idx="4">
+                  <c:v>0.5</c:v>
+                </c:pt>
+                <c:pt idx="5">
+                  <c:v>0.5</c:v>
+                </c:pt>
+                <c:pt idx="6">
+                  <c:v>0.5</c:v>
+                </c:pt>
+                <c:pt idx="7">
+                  <c:v>0.5</c:v>
+                </c:pt>
+                <c:pt idx="8">
+                  <c:v>0.5</c:v>
+                </c:pt>
+                <c:pt idx="9">
+                  <c:v>0.5</c:v>
+                </c:pt>
+                <c:pt idx="10">
+                  <c:v>0.75</c:v>
+                </c:pt>
+                <c:pt idx="11">
+                  <c:v>0.75</c:v>
+                </c:pt>
+                <c:pt idx="12">
+                  <c:v>0.75</c:v>
+                </c:pt>
+                <c:pt idx="13">
+                  <c:v>0.75</c:v>
+                </c:pt>
+                <c:pt idx="14">
+                  <c:v>0.75</c:v>
+                </c:pt>
+                <c:pt idx="15">
+                  <c:v>0.75</c:v>
+                </c:pt>
+                <c:pt idx="16">
+                  <c:v>1.0</c:v>
+                </c:pt>
+                <c:pt idx="17">
+                  <c:v>1.0</c:v>
+                </c:pt>
+                <c:pt idx="18">
+                  <c:v>1.0</c:v>
+                </c:pt>
+                <c:pt idx="19">
+                  <c:v>1.0</c:v>
+                </c:pt>
+                <c:pt idx="20">
+                  <c:v>1.0</c:v>
+                </c:pt>
+                <c:pt idx="21">
+                  <c:v>1.0</c:v>
+                </c:pt>
+                <c:pt idx="22">
+                  <c:v>1.0</c:v>
+                </c:pt>
+                <c:pt idx="23">
+                  <c:v>1.0</c:v>
+                </c:pt>
+                <c:pt idx="24">
+                  <c:v>1.0</c:v>
+                </c:pt>
+                <c:pt idx="25">
+                  <c:v>1.0</c:v>
+                </c:pt>
+              </c:numCache>
+            </c:numRef>
+          </c:yVal>
+          <c:smooth val="0"/>
+        </c:ser>
+        <c:ser>
+          <c:idx val="1"/>
+          <c:order val="1"/>
+          <c:tx>
+            <c:strRef>
+              <c:f>Sheet1!$B$29</c:f>
+              <c:strCache>
+                <c:ptCount val="1"/>
+                <c:pt idx="0">
+                  <c:v>Formula (no ML)</c:v>
+                </c:pt>
+              </c:strCache>
+            </c:strRef>
+          </c:tx>
+          <c:spPr>
+            <a:ln w="19050">
+              <a:solidFill>
+                <a:srgbClr val="E07B24"/>
+              </a:solidFill>
+            </a:ln>
+          </c:spPr>
+          <c:marker>
+            <c:symbol val="none"/>
+          </c:marker>
+          <c:xVal>
+            <c:numRef>
+              <c:f>Sheet1!$A$30:$A$107</c:f>
+              <c:numCache>
+                <c:formatCode>General</c:formatCode>
+                <c:ptCount val="78"/>
+                <c:pt idx="0">
+                  <c:v>0.0</c:v>
+                </c:pt>
+                <c:pt idx="1">
+                  <c:v>0.0067</c:v>
+                </c:pt>
+                <c:pt idx="2">
+                  <c:v>0.0133</c:v>
+                </c:pt>
+                <c:pt idx="3">
+                  <c:v>0.02</c:v>
+                </c:pt>
+                <c:pt idx="4">
+                  <c:v>0.0267</c:v>
+                </c:pt>
+                <c:pt idx="5">
+                  <c:v>0.0333</c:v>
+                </c:pt>
+                <c:pt idx="6">
+                  <c:v>0.04</c:v>
+                </c:pt>
+                <c:pt idx="7">
+                  <c:v>0.0467</c:v>
+                </c:pt>
+                <c:pt idx="8">
+                  <c:v>0.0533</c:v>
+                </c:pt>
+                <c:pt idx="9">
+                  <c:v>0.06</c:v>
+                </c:pt>
+                <c:pt idx="10">
+                  <c:v>0.0733</c:v>
+                </c:pt>
+                <c:pt idx="11">
+                  <c:v>0.08</c:v>
+                </c:pt>
+                <c:pt idx="12">
+                  <c:v>0.0867</c:v>
+                </c:pt>
+                <c:pt idx="13">
+                  <c:v>0.0933</c:v>
+                </c:pt>
+                <c:pt idx="14">
+                  <c:v>0.1</c:v>
+                </c:pt>
+                <c:pt idx="15">
+                  <c:v>0.1067</c:v>
+                </c:pt>
+                <c:pt idx="16">
+                  <c:v>0.1133</c:v>
+                </c:pt>
+                <c:pt idx="17">
+                  <c:v>0.12</c:v>
+                </c:pt>
+                <c:pt idx="18">
+                  <c:v>0.1333</c:v>
+                </c:pt>
+                <c:pt idx="19">
+                  <c:v>0.14</c:v>
+                </c:pt>
+                <c:pt idx="20">
+                  <c:v>0.1467</c:v>
+                </c:pt>
+                <c:pt idx="21">
+                  <c:v>0.1533</c:v>
+                </c:pt>
+                <c:pt idx="22">
+                  <c:v>0.1667</c:v>
+                </c:pt>
+                <c:pt idx="23">
+                  <c:v>0.1733</c:v>
+                </c:pt>
+                <c:pt idx="24">
+                  <c:v>0.18</c:v>
+                </c:pt>
+                <c:pt idx="25">
+                  <c:v>0.1933</c:v>
+                </c:pt>
+                <c:pt idx="26">
+                  <c:v>0.2</c:v>
+                </c:pt>
+                <c:pt idx="27">
+                  <c:v>0.2067</c:v>
+                </c:pt>
+                <c:pt idx="28">
+                  <c:v>0.2133</c:v>
+                </c:pt>
+                <c:pt idx="29">
+                  <c:v>0.2267</c:v>
+                </c:pt>
+                <c:pt idx="30">
+                  <c:v>0.2333</c:v>
+                </c:pt>
+                <c:pt idx="31">
+                  <c:v>0.24</c:v>
+                </c:pt>
+                <c:pt idx="32">
+                  <c:v>0.2467</c:v>
+                </c:pt>
+                <c:pt idx="33">
+                  <c:v>0.2667</c:v>
+                </c:pt>
+                <c:pt idx="34">
+                  <c:v>0.28</c:v>
+                </c:pt>
+                <c:pt idx="35">
+                  <c:v>0.3</c:v>
+                </c:pt>
+                <c:pt idx="36">
+                  <c:v>0.3067</c:v>
+                </c:pt>
+                <c:pt idx="37">
+                  <c:v>0.3133</c:v>
+                </c:pt>
+                <c:pt idx="38">
+                  <c:v>0.32</c:v>
+                </c:pt>
+                <c:pt idx="39">
+                  <c:v>0.3333</c:v>
+                </c:pt>
+                <c:pt idx="40">
+                  <c:v>0.34</c:v>
+                </c:pt>
+                <c:pt idx="41">
+                  <c:v>0.3467</c:v>
+                </c:pt>
+                <c:pt idx="42">
+                  <c:v>0.3533</c:v>
+                </c:pt>
+                <c:pt idx="43">
+                  <c:v>0.36</c:v>
+                </c:pt>
+                <c:pt idx="44">
+                  <c:v>0.38</c:v>
+                </c:pt>
+                <c:pt idx="45">
+                  <c:v>0.4</c:v>
+                </c:pt>
+                <c:pt idx="46">
+                  <c:v>0.4133</c:v>
+                </c:pt>
+                <c:pt idx="47">
+                  <c:v>0.4333</c:v>
+                </c:pt>
+                <c:pt idx="48">
+                  <c:v>0.4667</c:v>
+                </c:pt>
+                <c:pt idx="49">
+                  <c:v>0.48</c:v>
+                </c:pt>
+                <c:pt idx="50">
+                  <c:v>0.4933</c:v>
+                </c:pt>
+                <c:pt idx="51">
+                  <c:v>0.5133</c:v>
+                </c:pt>
+                <c:pt idx="52">
+                  <c:v>0.54</c:v>
+                </c:pt>
+                <c:pt idx="53">
+                  <c:v>0.6467</c:v>
+                </c:pt>
+                <c:pt idx="54">
+                  <c:v>0.6533</c:v>
+                </c:pt>
+                <c:pt idx="55">
+                  <c:v>0.66</c:v>
+                </c:pt>
+                <c:pt idx="56">
+                  <c:v>0.6667</c:v>
+                </c:pt>
+                <c:pt idx="57">
+                  <c:v>0.6733</c:v>
+                </c:pt>
+                <c:pt idx="58">
+                  <c:v>0.68</c:v>
+                </c:pt>
+                <c:pt idx="59">
+                  <c:v>0.6867</c:v>
+                </c:pt>
+                <c:pt idx="60">
+                  <c:v>0.6933</c:v>
+                </c:pt>
+                <c:pt idx="61">
+                  <c:v>0.7133</c:v>
+                </c:pt>
+                <c:pt idx="62">
+                  <c:v>0.7267</c:v>
+                </c:pt>
+                <c:pt idx="63">
+                  <c:v>0.7333</c:v>
+                </c:pt>
+                <c:pt idx="64">
+                  <c:v>0.74</c:v>
+                </c:pt>
+                <c:pt idx="65">
+                  <c:v>0.7533</c:v>
+                </c:pt>
+                <c:pt idx="66">
+                  <c:v>0.76</c:v>
+                </c:pt>
+                <c:pt idx="67">
+                  <c:v>0.78</c:v>
+                </c:pt>
+                <c:pt idx="68">
+                  <c:v>0.8</c:v>
+                </c:pt>
+                <c:pt idx="69">
+                  <c:v>0.8933</c:v>
+                </c:pt>
+                <c:pt idx="70">
+                  <c:v>0.9267</c:v>
+                </c:pt>
+                <c:pt idx="71">
+                  <c:v>0.9333</c:v>
+                </c:pt>
+                <c:pt idx="72">
+                  <c:v>0.94</c:v>
+                </c:pt>
+                <c:pt idx="73">
+                  <c:v>0.9533</c:v>
+                </c:pt>
+                <c:pt idx="74">
+                  <c:v>0.96</c:v>
+                </c:pt>
+                <c:pt idx="75">
+                  <c:v>0.9667</c:v>
+                </c:pt>
+                <c:pt idx="76">
+                  <c:v>0.9933</c:v>
+                </c:pt>
+                <c:pt idx="77">
+                  <c:v>1.0</c:v>
+                </c:pt>
+              </c:numCache>
+            </c:numRef>
+          </c:xVal>
+          <c:yVal>
+            <c:numRef>
+              <c:f>Sheet1!$B$30:$B$107</c:f>
+              <c:numCache>
+                <c:formatCode>General</c:formatCode>
+                <c:ptCount val="78"/>
+                <c:pt idx="0">
+                  <c:v>0.0</c:v>
+                </c:pt>
+                <c:pt idx="1">
+                  <c:v>0.0</c:v>
+                </c:pt>
+                <c:pt idx="2">
+                  <c:v>0.25</c:v>
+                </c:pt>
+                <c:pt idx="3">
+                  <c:v>0.5</c:v>
+                </c:pt>
+                <c:pt idx="4">
+                  <c:v>0.75</c:v>
+                </c:pt>
+                <c:pt idx="5">
+                  <c:v>0.75</c:v>
+                </c:pt>
+                <c:pt idx="6">
+                  <c:v>0.75</c:v>
+                </c:pt>
+                <c:pt idx="7">
+                  <c:v>0.75</c:v>
+                </c:pt>
+                <c:pt idx="8">
+                  <c:v>1.0</c:v>
+                </c:pt>
+                <c:pt idx="9">
+                  <c:v>1.0</c:v>
+                </c:pt>
+                <c:pt idx="10">
+                  <c:v>1.0</c:v>
+                </c:pt>
+                <c:pt idx="11">
+                  <c:v>1.0</c:v>
+                </c:pt>
+                <c:pt idx="12">
+                  <c:v>1.0</c:v>
+                </c:pt>
+                <c:pt idx="13">
+                  <c:v>1.0</c:v>
+                </c:pt>
+                <c:pt idx="14">
+                  <c:v>1.0</c:v>
+                </c:pt>
+                <c:pt idx="15">
+                  <c:v>1.0</c:v>
+                </c:pt>
+                <c:pt idx="16">
+                  <c:v>1.0</c:v>
+                </c:pt>
+                <c:pt idx="17">
+                  <c:v>1.0</c:v>
+                </c:pt>
+                <c:pt idx="18">
+                  <c:v>1.0</c:v>
+                </c:pt>
+                <c:pt idx="19">
+                  <c:v>1.0</c:v>
+                </c:pt>
+                <c:pt idx="20">
+                  <c:v>1.0</c:v>
+                </c:pt>
+                <c:pt idx="21">
+                  <c:v>1.0</c:v>
+                </c:pt>
+                <c:pt idx="22">
+                  <c:v>1.0</c:v>
+                </c:pt>
+                <c:pt idx="23">
+                  <c:v>1.0</c:v>
+                </c:pt>
+                <c:pt idx="24">
+                  <c:v>1.0</c:v>
+                </c:pt>
+                <c:pt idx="25">
+                  <c:v>1.0</c:v>
+                </c:pt>
+                <c:pt idx="26">
+                  <c:v>1.0</c:v>
+                </c:pt>
+                <c:pt idx="27">
+                  <c:v>1.0</c:v>
+                </c:pt>
+                <c:pt idx="28">
+                  <c:v>1.0</c:v>
+                </c:pt>
+                <c:pt idx="29">
+                  <c:v>1.0</c:v>
+                </c:pt>
+                <c:pt idx="30">
+                  <c:v>1.0</c:v>
+                </c:pt>
+                <c:pt idx="31">
+                  <c:v>1.0</c:v>
+                </c:pt>
+                <c:pt idx="32">
+                  <c:v>1.0</c:v>
+                </c:pt>
+                <c:pt idx="33">
+                  <c:v>1.0</c:v>
+                </c:pt>
+                <c:pt idx="34">
+                  <c:v>1.0</c:v>
+                </c:pt>
+                <c:pt idx="35">
+                  <c:v>1.0</c:v>
+                </c:pt>
+                <c:pt idx="36">
+                  <c:v>1.0</c:v>
+                </c:pt>
+                <c:pt idx="37">
+                  <c:v>1.0</c:v>
+                </c:pt>
+                <c:pt idx="38">
+                  <c:v>1.0</c:v>
+                </c:pt>
+                <c:pt idx="39">
+                  <c:v>1.0</c:v>
+                </c:pt>
+                <c:pt idx="40">
+                  <c:v>1.0</c:v>
+                </c:pt>
+                <c:pt idx="41">
+                  <c:v>1.0</c:v>
+                </c:pt>
+                <c:pt idx="42">
+                  <c:v>1.0</c:v>
+                </c:pt>
+                <c:pt idx="43">
+                  <c:v>1.0</c:v>
+                </c:pt>
+                <c:pt idx="44">
+                  <c:v>1.0</c:v>
+                </c:pt>
+                <c:pt idx="45">
+                  <c:v>1.0</c:v>
+                </c:pt>
+                <c:pt idx="46">
+                  <c:v>1.0</c:v>
+                </c:pt>
+                <c:pt idx="47">
+                  <c:v>1.0</c:v>
+                </c:pt>
+                <c:pt idx="48">
+                  <c:v>1.0</c:v>
+                </c:pt>
+                <c:pt idx="49">
+                  <c:v>1.0</c:v>
+                </c:pt>
+                <c:pt idx="50">
+                  <c:v>1.0</c:v>
+                </c:pt>
+                <c:pt idx="51">
+                  <c:v>1.0</c:v>
+                </c:pt>
+                <c:pt idx="52">
+                  <c:v>1.0</c:v>
+                </c:pt>
+                <c:pt idx="53">
+                  <c:v>1.0</c:v>
+                </c:pt>
+                <c:pt idx="54">
+                  <c:v>1.0</c:v>
+                </c:pt>
+                <c:pt idx="55">
+                  <c:v>1.0</c:v>
+                </c:pt>
+                <c:pt idx="56">
+                  <c:v>1.0</c:v>
+                </c:pt>
+                <c:pt idx="57">
+                  <c:v>1.0</c:v>
+                </c:pt>
+                <c:pt idx="58">
+                  <c:v>1.0</c:v>
+                </c:pt>
+                <c:pt idx="59">
+                  <c:v>1.0</c:v>
+                </c:pt>
+                <c:pt idx="60">
+                  <c:v>1.0</c:v>
+                </c:pt>
+                <c:pt idx="61">
+                  <c:v>1.0</c:v>
+                </c:pt>
+                <c:pt idx="62">
+                  <c:v>1.0</c:v>
+                </c:pt>
+                <c:pt idx="63">
+                  <c:v>1.0</c:v>
+                </c:pt>
+                <c:pt idx="64">
+                  <c:v>1.0</c:v>
+                </c:pt>
+                <c:pt idx="65">
+                  <c:v>1.0</c:v>
+                </c:pt>
+                <c:pt idx="66">
+                  <c:v>1.0</c:v>
+                </c:pt>
+                <c:pt idx="67">
+                  <c:v>1.0</c:v>
+                </c:pt>
+                <c:pt idx="68">
+                  <c:v>1.0</c:v>
+                </c:pt>
+                <c:pt idx="69">
+                  <c:v>1.0</c:v>
+                </c:pt>
+                <c:pt idx="70">
+                  <c:v>1.0</c:v>
+                </c:pt>
+                <c:pt idx="71">
+                  <c:v>1.0</c:v>
+                </c:pt>
+                <c:pt idx="72">
+                  <c:v>1.0</c:v>
+                </c:pt>
+                <c:pt idx="73">
+                  <c:v>1.0</c:v>
+                </c:pt>
+                <c:pt idx="74">
+                  <c:v>1.0</c:v>
+                </c:pt>
+                <c:pt idx="75">
+                  <c:v>1.0</c:v>
+                </c:pt>
+                <c:pt idx="76">
+                  <c:v>1.0</c:v>
+                </c:pt>
+                <c:pt idx="77">
+                  <c:v>1.0</c:v>
+                </c:pt>
+              </c:numCache>
+            </c:numRef>
+          </c:yVal>
+          <c:smooth val="0"/>
+        </c:ser>
+        <c:ser>
+          <c:idx val="2"/>
+          <c:order val="2"/>
+          <c:tx>
+            <c:strRef>
+              <c:f>Sheet1!$B$109</c:f>
+              <c:strCache>
+                <c:ptCount val="1"/>
+                <c:pt idx="0">
+                  <c:v>Formula + ML</c:v>
+                </c:pt>
+              </c:strCache>
+            </c:strRef>
+          </c:tx>
+          <c:spPr>
+            <a:ln w="34925">
+              <a:solidFill>
+                <a:srgbClr val="1B998B"/>
+              </a:solidFill>
+            </a:ln>
+          </c:spPr>
+          <c:marker>
+            <c:symbol val="none"/>
+          </c:marker>
+          <c:xVal>
+            <c:numRef>
+              <c:f>Sheet1!$A$110:$A$259</c:f>
+              <c:numCache>
+                <c:formatCode>General</c:formatCode>
+                <c:ptCount val="150"/>
+                <c:pt idx="0">
+                  <c:v>0.0</c:v>
+                </c:pt>
+                <c:pt idx="1">
+                  <c:v>0.0067</c:v>
+                </c:pt>
+                <c:pt idx="2">
+                  <c:v>0.0133</c:v>
+                </c:pt>
+                <c:pt idx="3">
+                  <c:v>0.02</c:v>
+                </c:pt>
+                <c:pt idx="4">
+                  <c:v>0.0267</c:v>
+                </c:pt>
+                <c:pt idx="5">
+                  <c:v>0.0333</c:v>
+                </c:pt>
+                <c:pt idx="6">
+                  <c:v>0.04</c:v>
+                </c:pt>
+                <c:pt idx="7">
+                  <c:v>0.0467</c:v>
+                </c:pt>
+                <c:pt idx="8">
+                  <c:v>0.0533</c:v>
+                </c:pt>
+                <c:pt idx="9">
+                  <c:v>0.06</c:v>
+                </c:pt>
+                <c:pt idx="10">
+                  <c:v>0.0667</c:v>
+                </c:pt>
+                <c:pt idx="11">
+                  <c:v>0.0733</c:v>
+                </c:pt>
+                <c:pt idx="12">
+                  <c:v>0.08</c:v>
+                </c:pt>
+                <c:pt idx="13">
+                  <c:v>0.0867</c:v>
+                </c:pt>
+                <c:pt idx="14">
+                  <c:v>0.0933</c:v>
+                </c:pt>
+                <c:pt idx="15">
+                  <c:v>0.1</c:v>
+                </c:pt>
+                <c:pt idx="16">
+                  <c:v>0.1067</c:v>
+                </c:pt>
+                <c:pt idx="17">
+                  <c:v>0.1133</c:v>
+                </c:pt>
+                <c:pt idx="18">
+                  <c:v>0.12</c:v>
+                </c:pt>
+                <c:pt idx="19">
+                  <c:v>0.1267</c:v>
+                </c:pt>
+                <c:pt idx="20">
+                  <c:v>0.1333</c:v>
+                </c:pt>
+                <c:pt idx="21">
+                  <c:v>0.14</c:v>
+                </c:pt>
+                <c:pt idx="22">
+                  <c:v>0.1467</c:v>
+                </c:pt>
+                <c:pt idx="23">
+                  <c:v>0.1533</c:v>
+                </c:pt>
+                <c:pt idx="24">
+                  <c:v>0.16</c:v>
+                </c:pt>
+                <c:pt idx="25">
+                  <c:v>0.1667</c:v>
+                </c:pt>
+                <c:pt idx="26">
+                  <c:v>0.1733</c:v>
+                </c:pt>
+                <c:pt idx="27">
+                  <c:v>0.18</c:v>
+                </c:pt>
+                <c:pt idx="28">
+                  <c:v>0.1867</c:v>
+                </c:pt>
+                <c:pt idx="29">
+                  <c:v>0.1933</c:v>
+                </c:pt>
+                <c:pt idx="30">
+                  <c:v>0.2</c:v>
+                </c:pt>
+                <c:pt idx="31">
+                  <c:v>0.2067</c:v>
+                </c:pt>
+                <c:pt idx="32">
+                  <c:v>0.2133</c:v>
+                </c:pt>
+                <c:pt idx="33">
+                  <c:v>0.22</c:v>
+                </c:pt>
+                <c:pt idx="34">
+                  <c:v>0.2267</c:v>
+                </c:pt>
+                <c:pt idx="35">
+                  <c:v>0.2333</c:v>
+                </c:pt>
+                <c:pt idx="36">
+                  <c:v>0.24</c:v>
+                </c:pt>
+                <c:pt idx="37">
+                  <c:v>0.2467</c:v>
+                </c:pt>
+                <c:pt idx="38">
+                  <c:v>0.2533</c:v>
+                </c:pt>
+                <c:pt idx="39">
+                  <c:v>0.26</c:v>
+                </c:pt>
+                <c:pt idx="40">
+                  <c:v>0.2667</c:v>
+                </c:pt>
+                <c:pt idx="41">
+                  <c:v>0.2733</c:v>
+                </c:pt>
+                <c:pt idx="42">
+                  <c:v>0.28</c:v>
+                </c:pt>
+                <c:pt idx="43">
+                  <c:v>0.2867</c:v>
+                </c:pt>
+                <c:pt idx="44">
+                  <c:v>0.2933</c:v>
+                </c:pt>
+                <c:pt idx="45">
+                  <c:v>0.3</c:v>
+                </c:pt>
+                <c:pt idx="46">
+                  <c:v>0.3067</c:v>
+                </c:pt>
+                <c:pt idx="47">
+                  <c:v>0.3133</c:v>
+                </c:pt>
+                <c:pt idx="48">
+                  <c:v>0.32</c:v>
+                </c:pt>
+                <c:pt idx="49">
+                  <c:v>0.3267</c:v>
+                </c:pt>
+                <c:pt idx="50">
+                  <c:v>0.3333</c:v>
+                </c:pt>
+                <c:pt idx="51">
+                  <c:v>0.34</c:v>
+                </c:pt>
+                <c:pt idx="52">
+                  <c:v>0.3467</c:v>
+                </c:pt>
+                <c:pt idx="53">
+                  <c:v>0.3533</c:v>
+                </c:pt>
+                <c:pt idx="54">
+                  <c:v>0.36</c:v>
+                </c:pt>
+                <c:pt idx="55">
+                  <c:v>0.3667</c:v>
+                </c:pt>
+                <c:pt idx="56">
+                  <c:v>0.3733</c:v>
+                </c:pt>
+                <c:pt idx="57">
+                  <c:v>0.38</c:v>
+                </c:pt>
+                <c:pt idx="58">
+                  <c:v>0.3867</c:v>
+                </c:pt>
+                <c:pt idx="59">
+                  <c:v>0.3933</c:v>
+                </c:pt>
+                <c:pt idx="60">
+                  <c:v>0.4</c:v>
+                </c:pt>
+                <c:pt idx="61">
+                  <c:v>0.4067</c:v>
+                </c:pt>
+                <c:pt idx="62">
+                  <c:v>0.4133</c:v>
+                </c:pt>
+                <c:pt idx="63">
+                  <c:v>0.42</c:v>
+                </c:pt>
+                <c:pt idx="64">
+                  <c:v>0.4267</c:v>
+                </c:pt>
+                <c:pt idx="65">
+                  <c:v>0.4333</c:v>
+                </c:pt>
+                <c:pt idx="66">
+                  <c:v>0.44</c:v>
+                </c:pt>
+                <c:pt idx="67">
+                  <c:v>0.4467</c:v>
+                </c:pt>
+                <c:pt idx="68">
+                  <c:v>0.4533</c:v>
+                </c:pt>
+                <c:pt idx="69">
+                  <c:v>0.46</c:v>
+                </c:pt>
+                <c:pt idx="70">
+                  <c:v>0.4667</c:v>
+                </c:pt>
+                <c:pt idx="71">
+                  <c:v>0.4733</c:v>
+                </c:pt>
+                <c:pt idx="72">
+                  <c:v>0.48</c:v>
+                </c:pt>
+                <c:pt idx="73">
+                  <c:v>0.4867</c:v>
+                </c:pt>
+                <c:pt idx="74">
+                  <c:v>0.4933</c:v>
+                </c:pt>
+                <c:pt idx="75">
+                  <c:v>0.5</c:v>
+                </c:pt>
+                <c:pt idx="76">
+                  <c:v>0.5067</c:v>
+                </c:pt>
+                <c:pt idx="77">
+                  <c:v>0.5133</c:v>
+                </c:pt>
+                <c:pt idx="78">
+                  <c:v>0.52</c:v>
+                </c:pt>
+                <c:pt idx="79">
+                  <c:v>0.5267</c:v>
+                </c:pt>
+                <c:pt idx="80">
+                  <c:v>0.5333</c:v>
+                </c:pt>
+                <c:pt idx="81">
+                  <c:v>0.54</c:v>
+                </c:pt>
+                <c:pt idx="82">
+                  <c:v>0.5467</c:v>
+                </c:pt>
+                <c:pt idx="83">
+                  <c:v>0.5533</c:v>
+                </c:pt>
+                <c:pt idx="84">
+                  <c:v>0.56</c:v>
+                </c:pt>
+                <c:pt idx="85">
+                  <c:v>0.5667</c:v>
+                </c:pt>
+                <c:pt idx="86">
+                  <c:v>0.5733</c:v>
+                </c:pt>
+                <c:pt idx="87">
+                  <c:v>0.58</c:v>
+                </c:pt>
+                <c:pt idx="88">
+                  <c:v>0.5867</c:v>
+                </c:pt>
+                <c:pt idx="89">
+                  <c:v>0.5933</c:v>
+                </c:pt>
+                <c:pt idx="90">
+                  <c:v>0.6</c:v>
+                </c:pt>
+                <c:pt idx="91">
+                  <c:v>0.6067</c:v>
+                </c:pt>
+                <c:pt idx="92">
+                  <c:v>0.6133</c:v>
+                </c:pt>
+                <c:pt idx="93">
+                  <c:v>0.62</c:v>
+                </c:pt>
+                <c:pt idx="94">
+                  <c:v>0.6267</c:v>
+                </c:pt>
+                <c:pt idx="95">
+                  <c:v>0.6333</c:v>
+                </c:pt>
+                <c:pt idx="96">
+                  <c:v>0.64</c:v>
+                </c:pt>
+                <c:pt idx="97">
+                  <c:v>0.6467</c:v>
+                </c:pt>
+                <c:pt idx="98">
+                  <c:v>0.6533</c:v>
+                </c:pt>
+                <c:pt idx="99">
+                  <c:v>0.66</c:v>
+                </c:pt>
+                <c:pt idx="100">
+                  <c:v>0.6667</c:v>
+                </c:pt>
+                <c:pt idx="101">
+                  <c:v>0.6733</c:v>
+                </c:pt>
+                <c:pt idx="102">
+                  <c:v>0.68</c:v>
+                </c:pt>
+                <c:pt idx="103">
+                  <c:v>0.6867</c:v>
+                </c:pt>
+                <c:pt idx="104">
+                  <c:v>0.6933</c:v>
+                </c:pt>
+                <c:pt idx="105">
+                  <c:v>0.7</c:v>
+                </c:pt>
+                <c:pt idx="106">
+                  <c:v>0.7067</c:v>
+                </c:pt>
+                <c:pt idx="107">
+                  <c:v>0.7133</c:v>
+                </c:pt>
+                <c:pt idx="108">
+                  <c:v>0.72</c:v>
+                </c:pt>
+                <c:pt idx="109">
+                  <c:v>0.7267</c:v>
+                </c:pt>
+                <c:pt idx="110">
+                  <c:v>0.7333</c:v>
+                </c:pt>
+                <c:pt idx="111">
+                  <c:v>0.74</c:v>
+                </c:pt>
+                <c:pt idx="112">
+                  <c:v>0.7467</c:v>
+                </c:pt>
+                <c:pt idx="113">
+                  <c:v>0.7533</c:v>
+                </c:pt>
+                <c:pt idx="114">
+                  <c:v>0.76</c:v>
+                </c:pt>
+                <c:pt idx="115">
+                  <c:v>0.7667</c:v>
+                </c:pt>
+                <c:pt idx="116">
+                  <c:v>0.7733</c:v>
+                </c:pt>
+                <c:pt idx="117">
+                  <c:v>0.78</c:v>
+                </c:pt>
+                <c:pt idx="118">
+                  <c:v>0.7867</c:v>
+                </c:pt>
+                <c:pt idx="119">
+                  <c:v>0.7933</c:v>
+                </c:pt>
+                <c:pt idx="120">
+                  <c:v>0.8</c:v>
+                </c:pt>
+                <c:pt idx="121">
+                  <c:v>0.8067</c:v>
+                </c:pt>
+                <c:pt idx="122">
+                  <c:v>0.8133</c:v>
+                </c:pt>
+                <c:pt idx="123">
+                  <c:v>0.82</c:v>
+                </c:pt>
+                <c:pt idx="124">
+                  <c:v>0.8267</c:v>
+                </c:pt>
+                <c:pt idx="125">
+                  <c:v>0.84</c:v>
+                </c:pt>
+                <c:pt idx="126">
+                  <c:v>0.8467</c:v>
+                </c:pt>
+                <c:pt idx="127">
+                  <c:v>0.8533</c:v>
+                </c:pt>
+                <c:pt idx="128">
+                  <c:v>0.86</c:v>
+                </c:pt>
+                <c:pt idx="129">
+                  <c:v>0.8667</c:v>
+                </c:pt>
+                <c:pt idx="130">
+                  <c:v>0.8733</c:v>
+                </c:pt>
+                <c:pt idx="131">
+                  <c:v>0.88</c:v>
+                </c:pt>
+                <c:pt idx="132">
+                  <c:v>0.8867</c:v>
+                </c:pt>
+                <c:pt idx="133">
+                  <c:v>0.8933</c:v>
+                </c:pt>
+                <c:pt idx="134">
+                  <c:v>0.9</c:v>
+                </c:pt>
+                <c:pt idx="135">
+                  <c:v>0.9067</c:v>
+                </c:pt>
+                <c:pt idx="136">
+                  <c:v>0.9133</c:v>
+                </c:pt>
+                <c:pt idx="137">
+                  <c:v>0.92</c:v>
+                </c:pt>
+                <c:pt idx="138">
+                  <c:v>0.9267</c:v>
+                </c:pt>
+                <c:pt idx="139">
+                  <c:v>0.9333</c:v>
+                </c:pt>
+                <c:pt idx="140">
+                  <c:v>0.94</c:v>
+                </c:pt>
+                <c:pt idx="141">
+                  <c:v>0.9467</c:v>
+                </c:pt>
+                <c:pt idx="142">
+                  <c:v>0.9533</c:v>
+                </c:pt>
+                <c:pt idx="143">
+                  <c:v>0.96</c:v>
+                </c:pt>
+                <c:pt idx="144">
+                  <c:v>0.9667</c:v>
+                </c:pt>
+                <c:pt idx="145">
+                  <c:v>0.9733</c:v>
+                </c:pt>
+                <c:pt idx="146">
+                  <c:v>0.98</c:v>
+                </c:pt>
+                <c:pt idx="147">
+                  <c:v>0.9867</c:v>
+                </c:pt>
+                <c:pt idx="148">
+                  <c:v>0.9933</c:v>
+                </c:pt>
+                <c:pt idx="149">
+                  <c:v>1.0</c:v>
+                </c:pt>
+              </c:numCache>
+            </c:numRef>
+          </c:xVal>
+          <c:yVal>
+            <c:numRef>
+              <c:f>Sheet1!$B$110:$B$259</c:f>
+              <c:numCache>
+                <c:formatCode>General</c:formatCode>
+                <c:ptCount val="150"/>
+                <c:pt idx="0">
+                  <c:v>0.0</c:v>
+                </c:pt>
+                <c:pt idx="1">
+                  <c:v>0.0</c:v>
+                </c:pt>
+                <c:pt idx="2">
+                  <c:v>0.25</c:v>
+                </c:pt>
+                <c:pt idx="3">
+                  <c:v>0.5</c:v>
+                </c:pt>
+                <c:pt idx="4">
+                  <c:v>0.5</c:v>
+                </c:pt>
+                <c:pt idx="5">
+                  <c:v>0.75</c:v>
+                </c:pt>
+                <c:pt idx="6">
+                  <c:v>0.75</c:v>
+                </c:pt>
+                <c:pt idx="7">
+                  <c:v>0.75</c:v>
+                </c:pt>
+                <c:pt idx="8">
+                  <c:v>0.75</c:v>
+                </c:pt>
+                <c:pt idx="9">
+                  <c:v>0.75</c:v>
+                </c:pt>
+                <c:pt idx="10">
+                  <c:v>0.75</c:v>
+                </c:pt>
+                <c:pt idx="11">
+                  <c:v>0.75</c:v>
+                </c:pt>
+                <c:pt idx="12">
+                  <c:v>0.75</c:v>
+                </c:pt>
+                <c:pt idx="13">
+                  <c:v>0.75</c:v>
+                </c:pt>
+                <c:pt idx="14">
+                  <c:v>0.75</c:v>
+                </c:pt>
+                <c:pt idx="15">
+                  <c:v>1.0</c:v>
+                </c:pt>
+                <c:pt idx="16">
+                  <c:v>1.0</c:v>
+                </c:pt>
+                <c:pt idx="17">
+                  <c:v>1.0</c:v>
+                </c:pt>
+                <c:pt idx="18">
+                  <c:v>1.0</c:v>
+                </c:pt>
+                <c:pt idx="19">
+                  <c:v>1.0</c:v>
+                </c:pt>
+                <c:pt idx="20">
+                  <c:v>1.0</c:v>
+                </c:pt>
+                <c:pt idx="21">
+                  <c:v>1.0</c:v>
+                </c:pt>
+                <c:pt idx="22">
+                  <c:v>1.0</c:v>
+                </c:pt>
+                <c:pt idx="23">
+                  <c:v>1.0</c:v>
+                </c:pt>
+                <c:pt idx="24">
+                  <c:v>1.0</c:v>
+                </c:pt>
+                <c:pt idx="25">
+                  <c:v>1.0</c:v>
+                </c:pt>
+                <c:pt idx="26">
+                  <c:v>1.0</c:v>
+                </c:pt>
+                <c:pt idx="27">
+                  <c:v>1.0</c:v>
+                </c:pt>
+                <c:pt idx="28">
+                  <c:v>1.0</c:v>
+                </c:pt>
+                <c:pt idx="29">
+                  <c:v>1.0</c:v>
+                </c:pt>
+                <c:pt idx="30">
+                  <c:v>1.0</c:v>
+                </c:pt>
+                <c:pt idx="31">
+                  <c:v>1.0</c:v>
+                </c:pt>
+                <c:pt idx="32">
+                  <c:v>1.0</c:v>
+                </c:pt>
+                <c:pt idx="33">
+                  <c:v>1.0</c:v>
+                </c:pt>
+                <c:pt idx="34">
+                  <c:v>1.0</c:v>
+                </c:pt>
+                <c:pt idx="35">
+                  <c:v>1.0</c:v>
+                </c:pt>
+                <c:pt idx="36">
+                  <c:v>1.0</c:v>
+                </c:pt>
+                <c:pt idx="37">
+                  <c:v>1.0</c:v>
+                </c:pt>
+                <c:pt idx="38">
+                  <c:v>1.0</c:v>
+                </c:pt>
+                <c:pt idx="39">
+                  <c:v>1.0</c:v>
+                </c:pt>
+                <c:pt idx="40">
+                  <c:v>1.0</c:v>
+                </c:pt>
+                <c:pt idx="41">
+                  <c:v>1.0</c:v>
+                </c:pt>
+                <c:pt idx="42">
+                  <c:v>1.0</c:v>
+                </c:pt>
+                <c:pt idx="43">
+                  <c:v>1.0</c:v>
+                </c:pt>
+                <c:pt idx="44">
+                  <c:v>1.0</c:v>
+                </c:pt>
+                <c:pt idx="45">
+                  <c:v>1.0</c:v>
+                </c:pt>
+                <c:pt idx="46">
+                  <c:v>1.0</c:v>
+                </c:pt>
+                <c:pt idx="47">
+                  <c:v>1.0</c:v>
+                </c:pt>
+                <c:pt idx="48">
+                  <c:v>1.0</c:v>
+                </c:pt>
+                <c:pt idx="49">
+                  <c:v>1.0</c:v>
+                </c:pt>
+                <c:pt idx="50">
+                  <c:v>1.0</c:v>
+                </c:pt>
+                <c:pt idx="51">
+                  <c:v>1.0</c:v>
+                </c:pt>
+                <c:pt idx="52">
+                  <c:v>1.0</c:v>
+                </c:pt>
+                <c:pt idx="53">
+                  <c:v>1.0</c:v>
+                </c:pt>
+                <c:pt idx="54">
+                  <c:v>1.0</c:v>
+                </c:pt>
+                <c:pt idx="55">
+                  <c:v>1.0</c:v>
+                </c:pt>
+                <c:pt idx="56">
+                  <c:v>1.0</c:v>
+                </c:pt>
+                <c:pt idx="57">
+                  <c:v>1.0</c:v>
+                </c:pt>
+                <c:pt idx="58">
+                  <c:v>1.0</c:v>
+                </c:pt>
+                <c:pt idx="59">
+                  <c:v>1.0</c:v>
+                </c:pt>
+                <c:pt idx="60">
+                  <c:v>1.0</c:v>
+                </c:pt>
+                <c:pt idx="61">
+                  <c:v>1.0</c:v>
+                </c:pt>
+                <c:pt idx="62">
+                  <c:v>1.0</c:v>
+                </c:pt>
+                <c:pt idx="63">
+                  <c:v>1.0</c:v>
+                </c:pt>
+                <c:pt idx="64">
+                  <c:v>1.0</c:v>
+                </c:pt>
+                <c:pt idx="65">
+                  <c:v>1.0</c:v>
+                </c:pt>
+                <c:pt idx="66">
+                  <c:v>1.0</c:v>
+                </c:pt>
+                <c:pt idx="67">
+                  <c:v>1.0</c:v>
+                </c:pt>
+                <c:pt idx="68">
+                  <c:v>1.0</c:v>
+                </c:pt>
+                <c:pt idx="69">
+                  <c:v>1.0</c:v>
+                </c:pt>
+                <c:pt idx="70">
+                  <c:v>1.0</c:v>
+                </c:pt>
+                <c:pt idx="71">
+                  <c:v>1.0</c:v>
+                </c:pt>
+                <c:pt idx="72">
+                  <c:v>1.0</c:v>
+                </c:pt>
+                <c:pt idx="73">
+                  <c:v>1.0</c:v>
+                </c:pt>
+                <c:pt idx="74">
+                  <c:v>1.0</c:v>
+                </c:pt>
+                <c:pt idx="75">
+                  <c:v>1.0</c:v>
+                </c:pt>
+                <c:pt idx="76">
+                  <c:v>1.0</c:v>
+                </c:pt>
+                <c:pt idx="77">
+                  <c:v>1.0</c:v>
+                </c:pt>
+                <c:pt idx="78">
+                  <c:v>1.0</c:v>
+                </c:pt>
+                <c:pt idx="79">
+                  <c:v>1.0</c:v>
+                </c:pt>
+                <c:pt idx="80">
+                  <c:v>1.0</c:v>
+                </c:pt>
+                <c:pt idx="81">
+                  <c:v>1.0</c:v>
+                </c:pt>
+                <c:pt idx="82">
+                  <c:v>1.0</c:v>
+                </c:pt>
+                <c:pt idx="83">
+                  <c:v>1.0</c:v>
+                </c:pt>
+                <c:pt idx="84">
+                  <c:v>1.0</c:v>
+                </c:pt>
+                <c:pt idx="85">
+                  <c:v>1.0</c:v>
+                </c:pt>
+                <c:pt idx="86">
+                  <c:v>1.0</c:v>
+                </c:pt>
+                <c:pt idx="87">
+                  <c:v>1.0</c:v>
+                </c:pt>
+                <c:pt idx="88">
+                  <c:v>1.0</c:v>
+                </c:pt>
+                <c:pt idx="89">
+                  <c:v>1.0</c:v>
+                </c:pt>
+                <c:pt idx="90">
+                  <c:v>1.0</c:v>
+                </c:pt>
+                <c:pt idx="91">
+                  <c:v>1.0</c:v>
+                </c:pt>
+                <c:pt idx="92">
+                  <c:v>1.0</c:v>
+                </c:pt>
+                <c:pt idx="93">
+                  <c:v>1.0</c:v>
+                </c:pt>
+                <c:pt idx="94">
+                  <c:v>1.0</c:v>
+                </c:pt>
+                <c:pt idx="95">
+                  <c:v>1.0</c:v>
+                </c:pt>
+                <c:pt idx="96">
+                  <c:v>1.0</c:v>
+                </c:pt>
+                <c:pt idx="97">
+                  <c:v>1.0</c:v>
+                </c:pt>
+                <c:pt idx="98">
+                  <c:v>1.0</c:v>
+                </c:pt>
+                <c:pt idx="99">
+                  <c:v>1.0</c:v>
+                </c:pt>
+                <c:pt idx="100">
+                  <c:v>1.0</c:v>
+                </c:pt>
+                <c:pt idx="101">
+                  <c:v>1.0</c:v>
+                </c:pt>
+                <c:pt idx="102">
+                  <c:v>1.0</c:v>
+                </c:pt>
+                <c:pt idx="103">
+                  <c:v>1.0</c:v>
+                </c:pt>
+                <c:pt idx="104">
+                  <c:v>1.0</c:v>
+                </c:pt>
+                <c:pt idx="105">
+                  <c:v>1.0</c:v>
+                </c:pt>
+                <c:pt idx="106">
+                  <c:v>1.0</c:v>
+                </c:pt>
+                <c:pt idx="107">
+                  <c:v>1.0</c:v>
+                </c:pt>
+                <c:pt idx="108">
+                  <c:v>1.0</c:v>
+                </c:pt>
+                <c:pt idx="109">
+                  <c:v>1.0</c:v>
+                </c:pt>
+                <c:pt idx="110">
+                  <c:v>1.0</c:v>
+                </c:pt>
+                <c:pt idx="111">
+                  <c:v>1.0</c:v>
+                </c:pt>
+                <c:pt idx="112">
+                  <c:v>1.0</c:v>
+                </c:pt>
+                <c:pt idx="113">
+                  <c:v>1.0</c:v>
+                </c:pt>
+                <c:pt idx="114">
+                  <c:v>1.0</c:v>
+                </c:pt>
+                <c:pt idx="115">
+                  <c:v>1.0</c:v>
+                </c:pt>
+                <c:pt idx="116">
+                  <c:v>1.0</c:v>
+                </c:pt>
+                <c:pt idx="117">
+                  <c:v>1.0</c:v>
+                </c:pt>
+                <c:pt idx="118">
+                  <c:v>1.0</c:v>
+                </c:pt>
+                <c:pt idx="119">
+                  <c:v>1.0</c:v>
+                </c:pt>
+                <c:pt idx="120">
+                  <c:v>1.0</c:v>
+                </c:pt>
+                <c:pt idx="121">
+                  <c:v>1.0</c:v>
+                </c:pt>
+                <c:pt idx="122">
+                  <c:v>1.0</c:v>
+                </c:pt>
+                <c:pt idx="123">
+                  <c:v>1.0</c:v>
+                </c:pt>
+                <c:pt idx="124">
+                  <c:v>1.0</c:v>
+                </c:pt>
+                <c:pt idx="125">
+                  <c:v>1.0</c:v>
+                </c:pt>
+                <c:pt idx="126">
+                  <c:v>1.0</c:v>
+                </c:pt>
+                <c:pt idx="127">
+                  <c:v>1.0</c:v>
+                </c:pt>
+                <c:pt idx="128">
+                  <c:v>1.0</c:v>
+                </c:pt>
+                <c:pt idx="129">
+                  <c:v>1.0</c:v>
+                </c:pt>
+                <c:pt idx="130">
+                  <c:v>1.0</c:v>
+                </c:pt>
+                <c:pt idx="131">
+                  <c:v>1.0</c:v>
+                </c:pt>
+                <c:pt idx="132">
+                  <c:v>1.0</c:v>
+                </c:pt>
+                <c:pt idx="133">
+                  <c:v>1.0</c:v>
+                </c:pt>
+                <c:pt idx="134">
+                  <c:v>1.0</c:v>
+                </c:pt>
+                <c:pt idx="135">
+                  <c:v>1.0</c:v>
+                </c:pt>
+                <c:pt idx="136">
+                  <c:v>1.0</c:v>
+                </c:pt>
+                <c:pt idx="137">
+                  <c:v>1.0</c:v>
+                </c:pt>
+                <c:pt idx="138">
+                  <c:v>1.0</c:v>
+                </c:pt>
+                <c:pt idx="139">
+                  <c:v>1.0</c:v>
+                </c:pt>
+                <c:pt idx="140">
+                  <c:v>1.0</c:v>
+                </c:pt>
+                <c:pt idx="141">
+                  <c:v>1.0</c:v>
+                </c:pt>
+                <c:pt idx="142">
+                  <c:v>1.0</c:v>
+                </c:pt>
+                <c:pt idx="143">
+                  <c:v>1.0</c:v>
+                </c:pt>
+                <c:pt idx="144">
+                  <c:v>1.0</c:v>
+                </c:pt>
+                <c:pt idx="145">
+                  <c:v>1.0</c:v>
+                </c:pt>
+                <c:pt idx="146">
+                  <c:v>1.0</c:v>
+                </c:pt>
+                <c:pt idx="147">
+                  <c:v>1.0</c:v>
+                </c:pt>
+                <c:pt idx="148">
+                  <c:v>1.0</c:v>
+                </c:pt>
+                <c:pt idx="149">
+                  <c:v>1.0</c:v>
+                </c:pt>
+              </c:numCache>
+            </c:numRef>
+          </c:yVal>
+          <c:smooth val="0"/>
+        </c:ser>
+        <c:ser>
+          <c:idx val="3"/>
+          <c:order val="3"/>
+          <c:tx>
+            <c:strRef>
+              <c:f>Sheet1!$B$261</c:f>
+              <c:strCache>
+                <c:ptCount val="1"/>
+                <c:pt idx="0">
+                  <c:v>EPSS-only</c:v>
+                </c:pt>
+              </c:strCache>
+            </c:strRef>
+          </c:tx>
+          <c:spPr>
+            <a:ln w="19050">
+              <a:solidFill>
+                <a:srgbClr val="6A5ACD"/>
+              </a:solidFill>
+            </a:ln>
+          </c:spPr>
+          <c:marker>
+            <c:symbol val="none"/>
+          </c:marker>
+          <c:xVal>
+            <c:numRef>
+              <c:f>Sheet1!$A$262:$A$343</c:f>
+              <c:numCache>
+                <c:formatCode>General</c:formatCode>
+                <c:ptCount val="82"/>
+                <c:pt idx="0">
+                  <c:v>0.0</c:v>
+                </c:pt>
+                <c:pt idx="1">
+                  <c:v>0.0067</c:v>
+                </c:pt>
+                <c:pt idx="2">
+                  <c:v>0.0133</c:v>
+                </c:pt>
+                <c:pt idx="3">
+                  <c:v>0.02</c:v>
+                </c:pt>
+                <c:pt idx="4">
+                  <c:v>0.0267</c:v>
+                </c:pt>
+                <c:pt idx="5">
+                  <c:v>0.0333</c:v>
+                </c:pt>
+                <c:pt idx="6">
+                  <c:v>0.04</c:v>
+                </c:pt>
+                <c:pt idx="7">
+                  <c:v>0.0467</c:v>
+                </c:pt>
+                <c:pt idx="8">
+                  <c:v>0.0533</c:v>
+                </c:pt>
+                <c:pt idx="9">
+                  <c:v>0.06</c:v>
+                </c:pt>
+                <c:pt idx="10">
+                  <c:v>0.0667</c:v>
+                </c:pt>
+                <c:pt idx="11">
+                  <c:v>0.0733</c:v>
+                </c:pt>
+                <c:pt idx="12">
+                  <c:v>0.08</c:v>
+                </c:pt>
+                <c:pt idx="13">
+                  <c:v>0.0867</c:v>
+                </c:pt>
+                <c:pt idx="14">
+                  <c:v>0.0933</c:v>
+                </c:pt>
+                <c:pt idx="15">
+                  <c:v>0.1</c:v>
+                </c:pt>
+                <c:pt idx="16">
+                  <c:v>0.1067</c:v>
+                </c:pt>
+                <c:pt idx="17">
+                  <c:v>0.1133</c:v>
+                </c:pt>
+                <c:pt idx="18">
+                  <c:v>0.12</c:v>
+                </c:pt>
+                <c:pt idx="19">
+                  <c:v>0.1333</c:v>
+                </c:pt>
+                <c:pt idx="20">
+                  <c:v>0.14</c:v>
+                </c:pt>
+                <c:pt idx="21">
+                  <c:v>0.1467</c:v>
+                </c:pt>
+                <c:pt idx="22">
+                  <c:v>0.1533</c:v>
+                </c:pt>
+                <c:pt idx="23">
+                  <c:v>0.16</c:v>
+                </c:pt>
+                <c:pt idx="24">
+                  <c:v>0.1667</c:v>
+                </c:pt>
+                <c:pt idx="25">
+                  <c:v>0.1733</c:v>
+                </c:pt>
+                <c:pt idx="26">
+                  <c:v>0.1867</c:v>
+                </c:pt>
+                <c:pt idx="27">
+                  <c:v>0.2</c:v>
+                </c:pt>
+                <c:pt idx="28">
+                  <c:v>0.2067</c:v>
+                </c:pt>
+                <c:pt idx="29">
+                  <c:v>0.2133</c:v>
+                </c:pt>
+                <c:pt idx="30">
+                  <c:v>0.22</c:v>
+                </c:pt>
+                <c:pt idx="31">
+                  <c:v>0.2267</c:v>
+                </c:pt>
+                <c:pt idx="32">
+                  <c:v>0.24</c:v>
+                </c:pt>
+                <c:pt idx="33">
+                  <c:v>0.2467</c:v>
+                </c:pt>
+                <c:pt idx="34">
+                  <c:v>0.2533</c:v>
+                </c:pt>
+                <c:pt idx="35">
+                  <c:v>0.26</c:v>
+                </c:pt>
+                <c:pt idx="36">
+                  <c:v>0.2733</c:v>
+                </c:pt>
+                <c:pt idx="37">
+                  <c:v>0.2867</c:v>
+                </c:pt>
+                <c:pt idx="38">
+                  <c:v>0.2933</c:v>
+                </c:pt>
+                <c:pt idx="39">
+                  <c:v>0.3</c:v>
+                </c:pt>
+                <c:pt idx="40">
+                  <c:v>0.3133</c:v>
+                </c:pt>
+                <c:pt idx="41">
+                  <c:v>0.32</c:v>
+                </c:pt>
+                <c:pt idx="42">
+                  <c:v>0.3267</c:v>
+                </c:pt>
+                <c:pt idx="43">
+                  <c:v>0.34</c:v>
+                </c:pt>
+                <c:pt idx="44">
+                  <c:v>0.3467</c:v>
+                </c:pt>
+                <c:pt idx="45">
+                  <c:v>0.3533</c:v>
+                </c:pt>
+                <c:pt idx="46">
+                  <c:v>0.36</c:v>
+                </c:pt>
+                <c:pt idx="47">
+                  <c:v>0.3733</c:v>
+                </c:pt>
+                <c:pt idx="48">
+                  <c:v>0.38</c:v>
+                </c:pt>
+                <c:pt idx="49">
+                  <c:v>0.3867</c:v>
+                </c:pt>
+                <c:pt idx="50">
+                  <c:v>0.3933</c:v>
+                </c:pt>
+                <c:pt idx="51">
+                  <c:v>0.4067</c:v>
+                </c:pt>
+                <c:pt idx="52">
+                  <c:v>0.4133</c:v>
+                </c:pt>
+                <c:pt idx="53">
+                  <c:v>0.42</c:v>
+                </c:pt>
+                <c:pt idx="54">
+                  <c:v>0.4267</c:v>
+                </c:pt>
+                <c:pt idx="55">
+                  <c:v>0.44</c:v>
+                </c:pt>
+                <c:pt idx="56">
+                  <c:v>0.46</c:v>
+                </c:pt>
+                <c:pt idx="57">
+                  <c:v>0.48</c:v>
+                </c:pt>
+                <c:pt idx="58">
+                  <c:v>0.4933</c:v>
+                </c:pt>
+                <c:pt idx="59">
+                  <c:v>0.5067</c:v>
+                </c:pt>
+                <c:pt idx="60">
+                  <c:v>0.5133</c:v>
+                </c:pt>
+                <c:pt idx="61">
+                  <c:v>0.5333</c:v>
+                </c:pt>
+                <c:pt idx="62">
+                  <c:v>0.54</c:v>
+                </c:pt>
+                <c:pt idx="63">
+                  <c:v>0.5467</c:v>
+                </c:pt>
+                <c:pt idx="64">
+                  <c:v>0.56</c:v>
+                </c:pt>
+                <c:pt idx="65">
+                  <c:v>0.5667</c:v>
+                </c:pt>
+                <c:pt idx="66">
+                  <c:v>0.5733</c:v>
+                </c:pt>
+                <c:pt idx="67">
+                  <c:v>0.58</c:v>
+                </c:pt>
+                <c:pt idx="68">
+                  <c:v>0.5867</c:v>
+                </c:pt>
+                <c:pt idx="69">
+                  <c:v>0.6</c:v>
+                </c:pt>
+                <c:pt idx="70">
+                  <c:v>0.62</c:v>
+                </c:pt>
+                <c:pt idx="71">
+                  <c:v>0.6733</c:v>
+                </c:pt>
+                <c:pt idx="72">
+                  <c:v>0.68</c:v>
+                </c:pt>
+                <c:pt idx="73">
+                  <c:v>0.6867</c:v>
+                </c:pt>
+                <c:pt idx="74">
+                  <c:v>0.8933</c:v>
+                </c:pt>
+                <c:pt idx="75">
+                  <c:v>0.9</c:v>
+                </c:pt>
+                <c:pt idx="76">
+                  <c:v>0.92</c:v>
+                </c:pt>
+                <c:pt idx="77">
+                  <c:v>0.94</c:v>
+                </c:pt>
+                <c:pt idx="78">
+                  <c:v>0.9467</c:v>
+                </c:pt>
+                <c:pt idx="79">
+                  <c:v>0.9867</c:v>
+                </c:pt>
+                <c:pt idx="80">
+                  <c:v>0.9933</c:v>
+                </c:pt>
+                <c:pt idx="81">
+                  <c:v>1.0</c:v>
+                </c:pt>
+              </c:numCache>
+            </c:numRef>
+          </c:xVal>
+          <c:yVal>
+            <c:numRef>
+              <c:f>Sheet1!$B$262:$B$343</c:f>
+              <c:numCache>
+                <c:formatCode>General</c:formatCode>
+                <c:ptCount val="82"/>
+                <c:pt idx="0">
+                  <c:v>0.0</c:v>
+                </c:pt>
+                <c:pt idx="1">
+                  <c:v>0.25</c:v>
+                </c:pt>
+                <c:pt idx="2">
+                  <c:v>0.5</c:v>
+                </c:pt>
+                <c:pt idx="3">
+                  <c:v>0.5</c:v>
+                </c:pt>
+                <c:pt idx="4">
+                  <c:v>0.75</c:v>
+                </c:pt>
+                <c:pt idx="5">
+                  <c:v>0.75</c:v>
+                </c:pt>
+                <c:pt idx="6">
+                  <c:v>0.75</c:v>
+                </c:pt>
+                <c:pt idx="7">
+                  <c:v>0.75</c:v>
+                </c:pt>
+                <c:pt idx="8">
+                  <c:v>0.75</c:v>
+                </c:pt>
+                <c:pt idx="9">
+                  <c:v>0.75</c:v>
+                </c:pt>
+                <c:pt idx="10">
+                  <c:v>0.75</c:v>
+                </c:pt>
+                <c:pt idx="11">
+                  <c:v>0.75</c:v>
+                </c:pt>
+                <c:pt idx="12">
+                  <c:v>0.75</c:v>
+                </c:pt>
+                <c:pt idx="13">
+                  <c:v>1.0</c:v>
+                </c:pt>
+                <c:pt idx="14">
+                  <c:v>1.0</c:v>
+                </c:pt>
+                <c:pt idx="15">
+                  <c:v>1.0</c:v>
+                </c:pt>
+                <c:pt idx="16">
+                  <c:v>1.0</c:v>
+                </c:pt>
+                <c:pt idx="17">
+                  <c:v>1.0</c:v>
+                </c:pt>
+                <c:pt idx="18">
+                  <c:v>1.0</c:v>
+                </c:pt>
+                <c:pt idx="19">
+                  <c:v>1.0</c:v>
+                </c:pt>
+                <c:pt idx="20">
+                  <c:v>1.0</c:v>
+                </c:pt>
+                <c:pt idx="21">
+                  <c:v>1.0</c:v>
+                </c:pt>
+                <c:pt idx="22">
+                  <c:v>1.0</c:v>
+                </c:pt>
+                <c:pt idx="23">
+                  <c:v>1.0</c:v>
+                </c:pt>
+                <c:pt idx="24">
+                  <c:v>1.0</c:v>
+                </c:pt>
+                <c:pt idx="25">
+                  <c:v>1.0</c:v>
+                </c:pt>
+                <c:pt idx="26">
+                  <c:v>1.0</c:v>
+                </c:pt>
+                <c:pt idx="27">
+                  <c:v>1.0</c:v>
+                </c:pt>
+                <c:pt idx="28">
+                  <c:v>1.0</c:v>
+                </c:pt>
+                <c:pt idx="29">
+                  <c:v>1.0</c:v>
+                </c:pt>
+                <c:pt idx="30">
+                  <c:v>1.0</c:v>
+                </c:pt>
+                <c:pt idx="31">
+                  <c:v>1.0</c:v>
+                </c:pt>
+                <c:pt idx="32">
+                  <c:v>1.0</c:v>
+                </c:pt>
+                <c:pt idx="33">
+                  <c:v>1.0</c:v>
+                </c:pt>
+                <c:pt idx="34">
+                  <c:v>1.0</c:v>
+                </c:pt>
+                <c:pt idx="35">
+                  <c:v>1.0</c:v>
+                </c:pt>
+                <c:pt idx="36">
+                  <c:v>1.0</c:v>
+                </c:pt>
+                <c:pt idx="37">
+                  <c:v>1.0</c:v>
+                </c:pt>
+                <c:pt idx="38">
+                  <c:v>1.0</c:v>
+                </c:pt>
+                <c:pt idx="39">
+                  <c:v>1.0</c:v>
+                </c:pt>
+                <c:pt idx="40">
+                  <c:v>1.0</c:v>
+                </c:pt>
+                <c:pt idx="41">
+                  <c:v>1.0</c:v>
+                </c:pt>
+                <c:pt idx="42">
+                  <c:v>1.0</c:v>
+                </c:pt>
+                <c:pt idx="43">
+                  <c:v>1.0</c:v>
+                </c:pt>
+                <c:pt idx="44">
+                  <c:v>1.0</c:v>
+                </c:pt>
+                <c:pt idx="45">
+                  <c:v>1.0</c:v>
+                </c:pt>
+                <c:pt idx="46">
+                  <c:v>1.0</c:v>
+                </c:pt>
+                <c:pt idx="47">
+                  <c:v>1.0</c:v>
+                </c:pt>
+                <c:pt idx="48">
+                  <c:v>1.0</c:v>
+                </c:pt>
+                <c:pt idx="49">
+                  <c:v>1.0</c:v>
+                </c:pt>
+                <c:pt idx="50">
+                  <c:v>1.0</c:v>
+                </c:pt>
+                <c:pt idx="51">
+                  <c:v>1.0</c:v>
+                </c:pt>
+                <c:pt idx="52">
+                  <c:v>1.0</c:v>
+                </c:pt>
+                <c:pt idx="53">
+                  <c:v>1.0</c:v>
+                </c:pt>
+                <c:pt idx="54">
+                  <c:v>1.0</c:v>
+                </c:pt>
+                <c:pt idx="55">
+                  <c:v>1.0</c:v>
+                </c:pt>
+                <c:pt idx="56">
+                  <c:v>1.0</c:v>
+                </c:pt>
+                <c:pt idx="57">
+                  <c:v>1.0</c:v>
+                </c:pt>
+                <c:pt idx="58">
+                  <c:v>1.0</c:v>
+                </c:pt>
+                <c:pt idx="59">
+                  <c:v>1.0</c:v>
+                </c:pt>
+                <c:pt idx="60">
+                  <c:v>1.0</c:v>
+                </c:pt>
+                <c:pt idx="61">
+                  <c:v>1.0</c:v>
+                </c:pt>
+                <c:pt idx="62">
+                  <c:v>1.0</c:v>
+                </c:pt>
+                <c:pt idx="63">
+                  <c:v>1.0</c:v>
+                </c:pt>
+                <c:pt idx="64">
+                  <c:v>1.0</c:v>
+                </c:pt>
+                <c:pt idx="65">
+                  <c:v>1.0</c:v>
+                </c:pt>
+                <c:pt idx="66">
+                  <c:v>1.0</c:v>
+                </c:pt>
+                <c:pt idx="67">
+                  <c:v>1.0</c:v>
+                </c:pt>
+                <c:pt idx="68">
+                  <c:v>1.0</c:v>
+                </c:pt>
+                <c:pt idx="69">
+                  <c:v>1.0</c:v>
+                </c:pt>
+                <c:pt idx="70">
+                  <c:v>1.0</c:v>
+                </c:pt>
+                <c:pt idx="71">
+                  <c:v>1.0</c:v>
+                </c:pt>
+                <c:pt idx="72">
+                  <c:v>1.0</c:v>
+                </c:pt>
+                <c:pt idx="73">
+                  <c:v>1.0</c:v>
+                </c:pt>
+                <c:pt idx="74">
+                  <c:v>1.0</c:v>
+                </c:pt>
+                <c:pt idx="75">
+                  <c:v>1.0</c:v>
+                </c:pt>
+                <c:pt idx="76">
+                  <c:v>1.0</c:v>
+                </c:pt>
+                <c:pt idx="77">
+                  <c:v>1.0</c:v>
+                </c:pt>
+                <c:pt idx="78">
+                  <c:v>1.0</c:v>
+                </c:pt>
+                <c:pt idx="79">
+                  <c:v>1.0</c:v>
+                </c:pt>
+                <c:pt idx="80">
+                  <c:v>1.0</c:v>
+                </c:pt>
+                <c:pt idx="81">
+                  <c:v>1.0</c:v>
+                </c:pt>
+              </c:numCache>
+            </c:numRef>
+          </c:yVal>
+          <c:smooth val="0"/>
+        </c:ser>
         <c:axId val="-2128940872"/>
         <c:axId val="-2129643912"/>
       </c:scatterChart>
@@ -12791,7 +14983,7 @@
                 </a:solidFill>
                 <a:cs typeface="Arial" panose="020B0604020202020204" pitchFamily="34" charset="0"/>
               </a:rPr>
-              <a:t>Date: 15 October 2026</a:t>
+              <a:t>Date: &lt;viva date&gt;</a:t>
             </a:r>
             <a:r>
               <a:rPr lang="en-US" sz="1400" baseline="30000" dirty="0">
@@ -13056,7 +15248,7 @@
               <a:rPr lang="en-US" sz="3600" dirty="0">
                 <a:cs typeface="Arial" panose="020B0604020202020204" pitchFamily="34" charset="0"/>
               </a:rPr>
-              <a:t>Backtest — Table 2</a:t>
+              <a:t>Backtest - Table 2</a:t>
             </a:r>
             <a:endParaRPr lang="en-IN" dirty="0"/>
           </a:p>
@@ -13115,7 +15307,7 @@
                 <a:ea typeface="+mn-ea"/>
                 <a:cs typeface="+mn-cs"/>
               </a:rPr>
-              <a:t>15 October 2026</a:t>
+              <a:t>&lt;viva date&gt;</a:t>
             </a:r>
             <a:endParaRPr kumimoji="0" lang="en-US" sz="1200" b="0" i="0" u="none" strike="noStrike" kern="1200" cap="none" spc="0" normalizeH="0" baseline="0" noProof="0" dirty="0">
               <a:ln>
@@ -13233,7 +15425,7 @@
         <p:spPr>
           <a:xfrm>
             <a:off x="457200" y="1554480"/>
-            <a:ext cx="3657600" cy="1874519"/>
+            <a:ext cx="3657600" cy="1600200"/>
           </a:xfrm>
           <a:prstGeom prst="roundRect">
             <a:avLst>
@@ -13277,7 +15469,7 @@
         <p:spPr>
           <a:xfrm>
             <a:off x="594360" y="1627632"/>
-            <a:ext cx="3383280" cy="1783080"/>
+            <a:ext cx="3383280" cy="1508760"/>
           </a:xfrm>
           <a:prstGeom prst="rect">
             <a:avLst/>
@@ -13296,16 +15488,16 @@
               </a:spcAft>
             </a:pPr>
             <a:r>
-              <a:rPr sz="3400" b="1" i="0">
+              <a:rPr sz="3000" b="1" i="0">
                 <a:solidFill>
                   <a:srgbClr val="1B998B"/>
                 </a:solidFill>
                 <a:latin typeface="Arial"/>
               </a:rPr>
-              <a:t>n/a</a:t>
-            </a:r>
-            <a:r>
-              <a:rPr sz="1600" b="0" i="0">
+              <a:t>19.3k</a:t>
+            </a:r>
+            <a:r>
+              <a:rPr sz="1500" b="0" i="0">
                 <a:solidFill>
                   <a:srgbClr val="FFFFFF"/>
                 </a:solidFill>
@@ -13314,13 +15506,13 @@
               <a:t>  vs  </a:t>
             </a:r>
             <a:r>
-              <a:rPr sz="3400" b="1" i="0">
+              <a:rPr sz="3000" b="1" i="0">
                 <a:solidFill>
                   <a:srgbClr val="F06A6E"/>
                 </a:solidFill>
                 <a:latin typeface="Arial"/>
               </a:rPr>
-              <a:t>n/a</a:t>
+              <a:t>42.1k</a:t>
             </a:r>
           </a:p>
           <a:p>
@@ -13336,7 +15528,7 @@
                 </a:solidFill>
                 <a:latin typeface="Arial"/>
               </a:rPr>
-              <a:t>of findings patched to cover 90% of the CVEs added to KEV after the freeze — Formula + ML vs CVSS-only</a:t>
+              <a:t>mean rank of the later-exploited CVEs, Formula + ML vs CVSS-only (population case, N = 150,296, lower is better)</a:t>
             </a:r>
           </a:p>
         </p:txBody>
@@ -13349,8 +15541,8 @@
         </p:nvSpPr>
         <p:spPr>
           <a:xfrm>
-            <a:off x="457200" y="3520440"/>
-            <a:ext cx="3657600" cy="914400"/>
+            <a:off x="457200" y="3200400"/>
+            <a:ext cx="3657600" cy="1691640"/>
           </a:xfrm>
           <a:prstGeom prst="rect">
             <a:avLst/>
@@ -13369,13 +15561,13 @@
               </a:spcAft>
             </a:pPr>
             <a:r>
-              <a:rPr sz="1100" b="0" i="0">
+              <a:rPr sz="1200" b="1" i="0">
                 <a:solidFill>
-                  <a:srgbClr val="6B6B6B"/>
+                  <a:srgbClr val="333333"/>
                 </a:solidFill>
                 <a:latin typeface="Arial"/>
               </a:rPr>
-              <a:t>Freeze 2025-01-01 · struts2-showcase: N = 36 findings, M = 0 later-exploited, 9 already in KEV.</a:t>
+              <a:t>Effort to cover 90% of later-exploited CVEs</a:t>
             </a:r>
           </a:p>
           <a:p>
@@ -13385,13 +15577,29 @@
               </a:spcAft>
             </a:pPr>
             <a:r>
-              <a:rPr sz="1100" b="0" i="0">
+              <a:rPr sz="1150" b="0" i="0">
                 <a:solidFill>
-                  <a:srgbClr val="6B6B6B"/>
+                  <a:srgbClr val="333333"/>
                 </a:solidFill>
                 <a:latin typeface="Arial"/>
               </a:rPr>
-              <a:t>Whole population before T (N = 190,242, M = 102): 51.9% vs 52.4%.</a:t>
+              <a:t>population: Formula + ML 36.7% · Formula 48.4% · CVSS 53.1% · EPSS 72.8%</a:t>
+            </a:r>
+          </a:p>
+          <a:p>
+            <a:pPr algn="l">
+              <a:spcAft>
+                <a:spcPts val="400"/>
+              </a:spcAft>
+            </a:pPr>
+            <a:r>
+              <a:rPr sz="1100" b="0" i="0">
+                <a:solidFill>
+                  <a:srgbClr val="333333"/>
+                </a:solidFill>
+                <a:latin typeface="Arial"/>
+              </a:rPr>
+              <a:t>Removing the ML probability costs +19.2 pp of patch effort (ablation).</a:t>
             </a:r>
           </a:p>
         </p:txBody>
@@ -13405,8 +15613,8 @@
           <p:nvPr/>
         </p:nvGraphicFramePr>
         <p:xfrm>
-          <a:off x="457200" y="4526280"/>
-          <a:ext cx="3657600" cy="1554480"/>
+          <a:off x="457200" y="4937760"/>
+          <a:ext cx="3657600" cy="1371600"/>
         </p:xfrm>
         <a:graphic>
           <a:graphicData uri="http://schemas.openxmlformats.org/drawingml/2006/table">
@@ -13415,12 +15623,12 @@
                 <a:tableStyleId>{5C22544A-7EE6-4342-B048-85BDC9FD1C3A}</a:tableStyleId>
               </a:tblPr>
               <a:tblGrid>
-                <a:gridCol w="1463040"/>
+                <a:gridCol w="1417320"/>
                 <a:gridCol w="777240"/>
-                <a:gridCol w="640080"/>
                 <a:gridCol w="777240"/>
+                <a:gridCol w="685800"/>
               </a:tblGrid>
-              <a:tr h="310896">
+              <a:tr h="274320">
                 <a:tc>
                   <a:txBody>
                     <a:bodyPr wrap="square"/>
@@ -13434,7 +15642,7 @@
                           </a:solidFill>
                           <a:latin typeface="Arial"/>
                         </a:rPr>
-                        <a:t>Ranking method</a:t>
+                        <a:t>kev-app: N=150, M=4</a:t>
                       </a:r>
                     </a:p>
                   </a:txBody>
@@ -13480,7 +15688,7 @@
                           </a:solidFill>
                           <a:latin typeface="Arial"/>
                         </a:rPr>
-                        <a:t>P@10</a:t>
+                        <a:t>P@10 open</a:t>
                       </a:r>
                     </a:p>
                   </a:txBody>
@@ -13514,7 +15722,7 @@
                   </a:tcPr>
                 </a:tc>
               </a:tr>
-              <a:tr h="310896">
+              <a:tr h="274320">
                 <a:tc>
                   <a:txBody>
                     <a:bodyPr wrap="square"/>
@@ -13551,7 +15759,7 @@
                           </a:solidFill>
                           <a:latin typeface="Arial"/>
                         </a:rPr>
-                        <a:t>n/a</a:t>
+                        <a:t>30.6</a:t>
                       </a:r>
                     </a:p>
                   </a:txBody>
@@ -13574,7 +15782,7 @@
                           </a:solidFill>
                           <a:latin typeface="Arial"/>
                         </a:rPr>
-                        <a:t>0.000</a:t>
+                        <a:t>0.200</a:t>
                       </a:r>
                     </a:p>
                   </a:txBody>
@@ -13597,7 +15805,7 @@
                           </a:solidFill>
                           <a:latin typeface="Arial"/>
                         </a:rPr>
-                        <a:t>n/a</a:t>
+                        <a:t>47.7%</a:t>
                       </a:r>
                     </a:p>
                   </a:txBody>
@@ -13608,7 +15816,7 @@
                   </a:tcPr>
                 </a:tc>
               </a:tr>
-              <a:tr h="310896">
+              <a:tr h="274320">
                 <a:tc>
                   <a:txBody>
                     <a:bodyPr wrap="square"/>
@@ -13622,7 +15830,7 @@
                           </a:solidFill>
                           <a:latin typeface="Arial"/>
                         </a:rPr>
-                        <a:t>Formula (Cap-1)</a:t>
+                        <a:t>Formula</a:t>
                       </a:r>
                     </a:p>
                   </a:txBody>
@@ -13645,7 +15853,7 @@
                           </a:solidFill>
                           <a:latin typeface="Arial"/>
                         </a:rPr>
-                        <a:t>n/a</a:t>
+                        <a:t>4.2</a:t>
                       </a:r>
                     </a:p>
                   </a:txBody>
@@ -13668,7 +15876,7 @@
                           </a:solidFill>
                           <a:latin typeface="Arial"/>
                         </a:rPr>
-                        <a:t>0.000</a:t>
+                        <a:t>0.400</a:t>
                       </a:r>
                     </a:p>
                   </a:txBody>
@@ -13691,7 +15899,7 @@
                           </a:solidFill>
                           <a:latin typeface="Arial"/>
                         </a:rPr>
-                        <a:t>n/a</a:t>
+                        <a:t>5.3%</a:t>
                       </a:r>
                     </a:p>
                   </a:txBody>
@@ -13702,7 +15910,7 @@
                   </a:tcPr>
                 </a:tc>
               </a:tr>
-              <a:tr h="310896">
+              <a:tr h="274320">
                 <a:tc>
                   <a:txBody>
                     <a:bodyPr wrap="square"/>
@@ -13739,7 +15947,7 @@
                           </a:solidFill>
                           <a:latin typeface="Arial"/>
                         </a:rPr>
-                        <a:t>n/a</a:t>
+                        <a:t>6.2</a:t>
                       </a:r>
                     </a:p>
                   </a:txBody>
@@ -13762,7 +15970,7 @@
                           </a:solidFill>
                           <a:latin typeface="Arial"/>
                         </a:rPr>
-                        <a:t>0.000</a:t>
+                        <a:t>0.300</a:t>
                       </a:r>
                     </a:p>
                   </a:txBody>
@@ -13785,7 +15993,7 @@
                           </a:solidFill>
                           <a:latin typeface="Arial"/>
                         </a:rPr>
-                        <a:t>n/a</a:t>
+                        <a:t>10.0%</a:t>
                       </a:r>
                     </a:p>
                   </a:txBody>
@@ -13796,7 +16004,7 @@
                   </a:tcPr>
                 </a:tc>
               </a:tr>
-              <a:tr h="310896">
+              <a:tr h="274320">
                 <a:tc>
                   <a:txBody>
                     <a:bodyPr wrap="square"/>
@@ -13833,7 +16041,7 @@
                           </a:solidFill>
                           <a:latin typeface="Arial"/>
                         </a:rPr>
-                        <a:t>n/a</a:t>
+                        <a:t>5.0</a:t>
                       </a:r>
                     </a:p>
                   </a:txBody>
@@ -13856,7 +16064,7 @@
                           </a:solidFill>
                           <a:latin typeface="Arial"/>
                         </a:rPr>
-                        <a:t>0.000</a:t>
+                        <a:t>0.300</a:t>
                       </a:r>
                     </a:p>
                   </a:txBody>
@@ -13879,7 +16087,7 @@
                           </a:solidFill>
                           <a:latin typeface="Arial"/>
                         </a:rPr>
-                        <a:t>n/a</a:t>
+                        <a:t>8.7%</a:t>
                       </a:r>
                     </a:p>
                   </a:txBody>
@@ -14034,7 +16242,7 @@
                 <a:ea typeface="+mn-ea"/>
                 <a:cs typeface="+mn-cs"/>
               </a:rPr>
-              <a:t>15 October 2026</a:t>
+              <a:t>&lt;viva date&gt;</a:t>
             </a:r>
             <a:endParaRPr kumimoji="0" lang="en-US" sz="1200" b="0" i="0" u="none" strike="noStrike" kern="1200" cap="none" spc="0" normalizeH="0" baseline="0" noProof="0" dirty="0">
               <a:ln>
@@ -14205,7 +16413,7 @@
                           </a:solidFill>
                           <a:latin typeface="Arial"/>
                         </a:rPr>
-                        <a:t>legacy-java-app: effort 90%</a:t>
+                        <a:t>kev-app: effort 90%</a:t>
                       </a:r>
                     </a:p>
                   </a:txBody>
@@ -14322,7 +16530,7 @@
                           </a:solidFill>
                           <a:latin typeface="Arial"/>
                         </a:rPr>
-                        <a:t>n/a</a:t>
+                        <a:t>10.0%</a:t>
                       </a:r>
                     </a:p>
                   </a:txBody>
@@ -14345,7 +16553,7 @@
                           </a:solidFill>
                           <a:latin typeface="Arial"/>
                         </a:rPr>
-                        <a:t>—</a:t>
+                        <a:t>+0.0 pp</a:t>
                       </a:r>
                     </a:p>
                   </a:txBody>
@@ -14368,7 +16576,7 @@
                           </a:solidFill>
                           <a:latin typeface="Arial"/>
                         </a:rPr>
-                        <a:t>51.9%</a:t>
+                        <a:t>36.7%</a:t>
                       </a:r>
                     </a:p>
                   </a:txBody>
@@ -14439,7 +16647,7 @@
                           </a:solidFill>
                           <a:latin typeface="Arial"/>
                         </a:rPr>
-                        <a:t>n/a</a:t>
+                        <a:t>8.7%</a:t>
                       </a:r>
                     </a:p>
                   </a:txBody>
@@ -14462,7 +16670,7 @@
                           </a:solidFill>
                           <a:latin typeface="Arial"/>
                         </a:rPr>
-                        <a:t>—</a:t>
+                        <a:t>-1.3 pp</a:t>
                       </a:r>
                     </a:p>
                   </a:txBody>
@@ -14485,7 +16693,7 @@
                           </a:solidFill>
                           <a:latin typeface="Arial"/>
                         </a:rPr>
-                        <a:t>68.2%</a:t>
+                        <a:t>55.9%</a:t>
                       </a:r>
                     </a:p>
                   </a:txBody>
@@ -14508,7 +16716,7 @@
                           </a:solidFill>
                           <a:latin typeface="Arial"/>
                         </a:rPr>
-                        <a:t>+16.3 pp</a:t>
+                        <a:t>+19.2 pp</a:t>
                       </a:r>
                     </a:p>
                   </a:txBody>
@@ -14556,7 +16764,7 @@
                           </a:solidFill>
                           <a:latin typeface="Arial"/>
                         </a:rPr>
-                        <a:t>n/a</a:t>
+                        <a:t>38.0%</a:t>
                       </a:r>
                     </a:p>
                   </a:txBody>
@@ -14579,7 +16787,7 @@
                           </a:solidFill>
                           <a:latin typeface="Arial"/>
                         </a:rPr>
-                        <a:t>—</a:t>
+                        <a:t>+28.0 pp</a:t>
                       </a:r>
                     </a:p>
                   </a:txBody>
@@ -14602,7 +16810,7 @@
                           </a:solidFill>
                           <a:latin typeface="Arial"/>
                         </a:rPr>
-                        <a:t>49.5%</a:t>
+                        <a:t>46.4%</a:t>
                       </a:r>
                     </a:p>
                   </a:txBody>
@@ -14625,7 +16833,7 @@
                           </a:solidFill>
                           <a:latin typeface="Arial"/>
                         </a:rPr>
-                        <a:t>-2.4 pp</a:t>
+                        <a:t>+9.7 pp</a:t>
                       </a:r>
                     </a:p>
                   </a:txBody>
@@ -14673,7 +16881,7 @@
                           </a:solidFill>
                           <a:latin typeface="Arial"/>
                         </a:rPr>
-                        <a:t>n/a</a:t>
+                        <a:t>10.0%</a:t>
                       </a:r>
                     </a:p>
                   </a:txBody>
@@ -14696,7 +16904,7 @@
                           </a:solidFill>
                           <a:latin typeface="Arial"/>
                         </a:rPr>
-                        <a:t>—</a:t>
+                        <a:t>+0.0 pp</a:t>
                       </a:r>
                     </a:p>
                   </a:txBody>
@@ -14719,7 +16927,7 @@
                           </a:solidFill>
                           <a:latin typeface="Arial"/>
                         </a:rPr>
-                        <a:t>51.9%</a:t>
+                        <a:t>36.6%</a:t>
                       </a:r>
                     </a:p>
                   </a:txBody>
@@ -14790,7 +16998,7 @@
                           </a:solidFill>
                           <a:latin typeface="Arial"/>
                         </a:rPr>
-                        <a:t>n/a</a:t>
+                        <a:t>14.7%</a:t>
                       </a:r>
                     </a:p>
                   </a:txBody>
@@ -14813,7 +17021,7 @@
                           </a:solidFill>
                           <a:latin typeface="Arial"/>
                         </a:rPr>
-                        <a:t>—</a:t>
+                        <a:t>+4.7 pp</a:t>
                       </a:r>
                     </a:p>
                   </a:txBody>
@@ -14907,7 +17115,7 @@
                           </a:solidFill>
                           <a:latin typeface="Arial"/>
                         </a:rPr>
-                        <a:t>n/a</a:t>
+                        <a:t>10.7%</a:t>
                       </a:r>
                     </a:p>
                   </a:txBody>
@@ -14930,7 +17138,7 @@
                           </a:solidFill>
                           <a:latin typeface="Arial"/>
                         </a:rPr>
-                        <a:t>—</a:t>
+                        <a:t>+0.7 pp</a:t>
                       </a:r>
                     </a:p>
                   </a:txBody>
@@ -14953,7 +17161,7 @@
                           </a:solidFill>
                           <a:latin typeface="Arial"/>
                         </a:rPr>
-                        <a:t>51.5%</a:t>
+                        <a:t>36.3%</a:t>
                       </a:r>
                     </a:p>
                   </a:txBody>
@@ -14976,7 +17184,7 @@
                           </a:solidFill>
                           <a:latin typeface="Arial"/>
                         </a:rPr>
-                        <a:t>-0.4 pp</a:t>
+                        <a:t>-0.3 pp</a:t>
                       </a:r>
                     </a:p>
                   </a:txBody>
@@ -15024,7 +17232,7 @@
                           </a:solidFill>
                           <a:latin typeface="Arial"/>
                         </a:rPr>
-                        <a:t>n/a</a:t>
+                        <a:t>10.7%</a:t>
                       </a:r>
                     </a:p>
                   </a:txBody>
@@ -15047,7 +17255,7 @@
                           </a:solidFill>
                           <a:latin typeface="Arial"/>
                         </a:rPr>
-                        <a:t>—</a:t>
+                        <a:t>+0.7 pp</a:t>
                       </a:r>
                     </a:p>
                   </a:txBody>
@@ -15202,7 +17410,7 @@
                 </a:solidFill>
                 <a:latin typeface="Arial"/>
               </a:rPr>
-              <a:t>ML probability: helps (+16.3 pp on population)</a:t>
+              <a:t>ML probability: helps (+19.2 pp on population)</a:t>
             </a:r>
           </a:p>
           <a:p>
@@ -15218,7 +17426,7 @@
                 </a:solidFill>
                 <a:latin typeface="Arial"/>
               </a:rPr>
-              <a:t>EPSS: hurts (-2.4 pp on population)</a:t>
+              <a:t>EPSS: helps (+9.7 pp on population)</a:t>
             </a:r>
           </a:p>
           <a:p>
@@ -15250,7 +17458,39 @@
                 </a:solidFill>
                 <a:latin typeface="Arial"/>
               </a:rPr>
-              <a:t>Scope multiplier: no measurable effect (-0.4 pp on population)</a:t>
+              <a:t>Blast radius (fan-in): helps (+4.7 pp on kev-app)</a:t>
+            </a:r>
+          </a:p>
+          <a:p>
+            <a:pPr algn="l">
+              <a:spcAft>
+                <a:spcPts val="400"/>
+              </a:spcAft>
+            </a:pPr>
+            <a:r>
+              <a:rPr sz="1200" b="0" i="0">
+                <a:solidFill>
+                  <a:srgbClr val="333333"/>
+                </a:solidFill>
+                <a:latin typeface="Arial"/>
+              </a:rPr>
+              <a:t>Scope multiplier: no measurable effect (-0.3 pp on population)</a:t>
+            </a:r>
+          </a:p>
+          <a:p>
+            <a:pPr algn="l">
+              <a:spcAft>
+                <a:spcPts val="400"/>
+              </a:spcAft>
+            </a:pPr>
+            <a:r>
+              <a:rPr sz="1200" b="0" i="0">
+                <a:solidFill>
+                  <a:srgbClr val="333333"/>
+                </a:solidFill>
+                <a:latin typeface="Arial"/>
+              </a:rPr>
+              <a:t>Asset criticality: helps (+0.7 pp on kev-app)</a:t>
             </a:r>
           </a:p>
           <a:p>
@@ -15432,7 +17672,7 @@
                 <a:ea typeface="+mn-ea"/>
                 <a:cs typeface="+mn-cs"/>
               </a:rPr>
-              <a:t>15 October 2026</a:t>
+              <a:t>&lt;viva date&gt;</a:t>
             </a:r>
             <a:endParaRPr kumimoji="0" lang="en-US" sz="1200" b="0" i="0" u="none" strike="noStrike" kern="1200" cap="none" spc="0" normalizeH="0" baseline="0" noProof="0" dirty="0">
               <a:ln>
@@ -16001,7 +18241,7 @@
                 <a:ea typeface="+mn-ea"/>
                 <a:cs typeface="+mn-cs"/>
               </a:rPr>
-              <a:t>15 October 2026</a:t>
+              <a:t>&lt;viva date&gt;</a:t>
             </a:r>
             <a:endParaRPr kumimoji="0" lang="en-US" sz="1200" b="0" i="0" u="none" strike="noStrike" kern="1200" cap="none" spc="0" normalizeH="0" baseline="0" noProof="0" dirty="0">
               <a:ln>
@@ -17631,7 +19871,7 @@
                 <a:ea typeface="+mn-ea"/>
                 <a:cs typeface="+mn-cs"/>
               </a:rPr>
-              <a:t>15 October 2026</a:t>
+              <a:t>&lt;viva date&gt;</a:t>
             </a:r>
             <a:endParaRPr kumimoji="0" lang="en-US" sz="1200" b="0" i="0" u="none" strike="noStrike" kern="1200" cap="none" spc="0" normalizeH="0" baseline="0" noProof="0">
               <a:ln>
@@ -17882,7 +20122,7 @@
                           </a:solidFill>
                           <a:latin typeface="Arial"/>
                         </a:rPr>
-                        <a:t>Model without EPSS: test AUC 0.916 vs CVSS 0.763</a:t>
+                        <a:t>Model without EPSS: test AUC 0.917 vs CVSS 0.765</a:t>
                       </a:r>
                     </a:p>
                   </a:txBody>
@@ -17953,7 +20193,7 @@
                           </a:solidFill>
                           <a:latin typeface="Arial"/>
                         </a:rPr>
-                        <a:t>Effort to cover 90% of later-exploited CVEs: n/a (ours) vs n/a (CVSS)</a:t>
+                        <a:t>Mean rank of later-exploited CVEs 19.3k (ours) vs 42.1k (CVSS); effort to cover 90%: 36.7% vs 53.1%</a:t>
                       </a:r>
                     </a:p>
                   </a:txBody>
@@ -18183,7 +20423,7 @@
                 </a:solidFill>
                 <a:latin typeface="Arial"/>
               </a:rPr>
-              <a:t>Numbers are read from site/model_meta.json and site/backtest.json by scripts/build_deck.py.</a:t>
+              <a:t>Numbers are read from site/model_meta.json and site/backtest.json by scripts/build_deck.py · results snapshot v1.0-cap2-dirty · generated 2026-09-24</a:t>
             </a:r>
           </a:p>
         </p:txBody>
@@ -18310,7 +20550,7 @@
                 <a:ea typeface="+mn-ea"/>
                 <a:cs typeface="+mn-cs"/>
               </a:rPr>
-              <a:t>15 October 2026</a:t>
+              <a:t>&lt;viva date&gt;</a:t>
             </a:r>
             <a:endParaRPr kumimoji="0" lang="en-US" sz="1200" b="0" i="0" u="none" strike="noStrike" kern="1200" cap="none" spc="0" normalizeH="0" baseline="0" noProof="0" dirty="0">
               <a:ln>
@@ -18863,7 +21103,7 @@
                 <a:ea typeface="+mn-ea"/>
                 <a:cs typeface="+mn-cs"/>
               </a:rPr>
-              <a:t>15 October 2026</a:t>
+              <a:t>&lt;viva date&gt;</a:t>
             </a:r>
             <a:endParaRPr kumimoji="0" lang="en-US" sz="1200" b="0" i="0" u="none" strike="noStrike" kern="1200" cap="none" spc="0" normalizeH="0" baseline="0" noProof="0">
               <a:ln>
@@ -19414,7 +21654,7 @@
                 <a:ea typeface="+mn-ea"/>
                 <a:cs typeface="+mn-cs"/>
               </a:rPr>
-              <a:t>15 October 2026</a:t>
+              <a:t>&lt;viva date&gt;</a:t>
             </a:r>
             <a:endParaRPr kumimoji="0" lang="en-US" sz="1200" b="0" i="0" u="none" strike="noStrike" kern="1200" cap="none" spc="0" normalizeH="0" baseline="0" noProof="0">
               <a:ln>
@@ -20706,7 +22946,7 @@
                 <a:ea typeface="+mn-ea"/>
                 <a:cs typeface="+mn-cs"/>
               </a:rPr>
-              <a:t>15 October 2026</a:t>
+              <a:t>&lt;viva date&gt;</a:t>
             </a:r>
             <a:endParaRPr kumimoji="0" lang="en-US" sz="1200" b="0" i="0" u="none" strike="noStrike" kern="1200" cap="none" spc="0" normalizeH="0" baseline="0" noProof="0" dirty="0">
               <a:ln>
@@ -21024,7 +23264,7 @@
                 <a:ea typeface="+mn-ea"/>
                 <a:cs typeface="+mn-cs"/>
               </a:rPr>
-              <a:t>15 October 2026</a:t>
+              <a:t>&lt;viva date&gt;</a:t>
             </a:r>
             <a:endParaRPr kumimoji="0" lang="en-US" sz="1200" b="0" i="0" u="none" strike="noStrike" kern="1200" cap="none" spc="0" normalizeH="0" baseline="0" noProof="0">
               <a:ln>
@@ -22908,7 +25148,7 @@
                 <a:ea typeface="+mn-ea"/>
                 <a:cs typeface="+mn-cs"/>
               </a:rPr>
-              <a:t>15 October 2026</a:t>
+              <a:t>&lt;viva date&gt;</a:t>
             </a:r>
             <a:endParaRPr kumimoji="0" lang="en-US" sz="1200" b="0" i="0" u="none" strike="noStrike" kern="1200" cap="none" spc="0" normalizeH="0" baseline="0" noProof="0">
               <a:ln>
@@ -23269,7 +25509,7 @@
                 <a:ea typeface="+mn-ea"/>
                 <a:cs typeface="+mn-cs"/>
               </a:rPr>
-              <a:t>15 October 2026</a:t>
+              <a:t>&lt;viva date&gt;</a:t>
             </a:r>
             <a:endParaRPr kumimoji="0" lang="en-US" sz="1200" b="0" i="0" u="none" strike="noStrike" kern="1200" cap="none" spc="0" normalizeH="0" baseline="0" noProof="0">
               <a:ln>
@@ -24146,7 +26386,7 @@
                 <a:ea typeface="+mn-ea"/>
                 <a:cs typeface="+mn-cs"/>
               </a:rPr>
-              <a:t>15 October 2026</a:t>
+              <a:t>&lt;viva date&gt;</a:t>
             </a:r>
             <a:endParaRPr kumimoji="0" lang="en-US" sz="1200" b="0" i="0" u="none" strike="noStrike" kern="1200" cap="none" spc="0" normalizeH="0" baseline="0" noProof="0">
               <a:ln>
@@ -24268,7 +26508,46 @@
       </p:sp>
       <p:sp>
         <p:nvSpPr>
-          <p:cNvPr id="9" name="Rounded Rectangle 8"/>
+          <p:cNvPr id="9" name="TextBox 8"/>
+          <p:cNvSpPr txBox="1"/>
+          <p:nvPr/>
+        </p:nvSpPr>
+        <p:spPr>
+          <a:xfrm>
+            <a:off x="457200" y="6199632"/>
+            <a:ext cx="11292840" cy="320040"/>
+          </a:xfrm>
+          <a:prstGeom prst="rect">
+            <a:avLst/>
+          </a:prstGeom>
+          <a:noFill/>
+        </p:spPr>
+        <p:txBody>
+          <a:bodyPr wrap="square" anchor="t" lIns="45720" rIns="45720">
+            <a:spAutoFit/>
+          </a:bodyPr>
+          <a:lstStyle/>
+          <a:p>
+            <a:pPr algn="l">
+              <a:spcAft>
+                <a:spcPts val="400"/>
+              </a:spcAft>
+            </a:pPr>
+            <a:r>
+              <a:rPr sz="1100" b="1" i="0">
+                <a:solidFill>
+                  <a:srgbClr val="E07B24"/>
+                </a:solidFill>
+                <a:latin typeface="Arial"/>
+              </a:rPr>
+              <a:t>Live system: https://akilkumarmn.github.io/sbom-risk-engine/</a:t>
+            </a:r>
+          </a:p>
+        </p:txBody>
+      </p:sp>
+      <p:sp>
+        <p:nvSpPr>
+          <p:cNvPr id="10" name="Rounded Rectangle 9"/>
           <p:cNvSpPr/>
           <p:nvPr/>
         </p:nvSpPr>
@@ -24312,7 +26591,7 @@
       </p:sp>
       <p:sp>
         <p:nvSpPr>
-          <p:cNvPr id="10" name="TextBox 9"/>
+          <p:cNvPr id="11" name="TextBox 10"/>
           <p:cNvSpPr txBox="1"/>
           <p:nvPr/>
         </p:nvSpPr>
@@ -24351,7 +26630,7 @@
       </p:sp>
       <p:sp>
         <p:nvSpPr>
-          <p:cNvPr id="11" name="Rounded Rectangle 10"/>
+          <p:cNvPr id="12" name="Rounded Rectangle 11"/>
           <p:cNvSpPr/>
           <p:nvPr/>
         </p:nvSpPr>
@@ -24395,7 +26674,7 @@
       </p:sp>
       <p:sp>
         <p:nvSpPr>
-          <p:cNvPr id="12" name="TextBox 11"/>
+          <p:cNvPr id="13" name="TextBox 12"/>
           <p:cNvSpPr txBox="1"/>
           <p:nvPr/>
         </p:nvSpPr>
@@ -24434,7 +26713,7 @@
       </p:sp>
       <p:sp>
         <p:nvSpPr>
-          <p:cNvPr id="13" name="Rounded Rectangle 12"/>
+          <p:cNvPr id="14" name="Rounded Rectangle 13"/>
           <p:cNvSpPr/>
           <p:nvPr/>
         </p:nvSpPr>
@@ -24478,7 +26757,7 @@
       </p:sp>
       <p:sp>
         <p:nvSpPr>
-          <p:cNvPr id="14" name="TextBox 13"/>
+          <p:cNvPr id="15" name="TextBox 14"/>
           <p:cNvSpPr txBox="1"/>
           <p:nvPr/>
         </p:nvSpPr>
@@ -24517,7 +26796,7 @@
       </p:sp>
       <p:sp>
         <p:nvSpPr>
-          <p:cNvPr id="15" name="Rounded Rectangle 14"/>
+          <p:cNvPr id="16" name="Rounded Rectangle 15"/>
           <p:cNvSpPr/>
           <p:nvPr/>
         </p:nvSpPr>
@@ -24563,7 +26842,7 @@
       </p:sp>
       <p:sp>
         <p:nvSpPr>
-          <p:cNvPr id="16" name="TextBox 15"/>
+          <p:cNvPr id="17" name="TextBox 16"/>
           <p:cNvSpPr txBox="1"/>
           <p:nvPr/>
         </p:nvSpPr>
@@ -24602,7 +26881,7 @@
       </p:sp>
       <p:sp>
         <p:nvSpPr>
-          <p:cNvPr id="17" name="Rounded Rectangle 16"/>
+          <p:cNvPr id="18" name="Rounded Rectangle 17"/>
           <p:cNvSpPr/>
           <p:nvPr/>
         </p:nvSpPr>
@@ -24648,7 +26927,7 @@
       </p:sp>
       <p:sp>
         <p:nvSpPr>
-          <p:cNvPr id="18" name="TextBox 17"/>
+          <p:cNvPr id="19" name="TextBox 18"/>
           <p:cNvSpPr txBox="1"/>
           <p:nvPr/>
         </p:nvSpPr>
@@ -24687,7 +26966,7 @@
       </p:sp>
       <p:sp>
         <p:nvSpPr>
-          <p:cNvPr id="19" name="Rounded Rectangle 18"/>
+          <p:cNvPr id="20" name="Rounded Rectangle 19"/>
           <p:cNvSpPr/>
           <p:nvPr/>
         </p:nvSpPr>
@@ -24733,7 +27012,7 @@
       </p:sp>
       <p:sp>
         <p:nvSpPr>
-          <p:cNvPr id="20" name="TextBox 19"/>
+          <p:cNvPr id="21" name="TextBox 20"/>
           <p:cNvSpPr txBox="1"/>
           <p:nvPr/>
         </p:nvSpPr>
@@ -24772,7 +27051,7 @@
       </p:sp>
       <p:sp>
         <p:nvSpPr>
-          <p:cNvPr id="21" name="Rounded Rectangle 20"/>
+          <p:cNvPr id="22" name="Rounded Rectangle 21"/>
           <p:cNvSpPr/>
           <p:nvPr/>
         </p:nvSpPr>
@@ -24818,7 +27097,7 @@
       </p:sp>
       <p:sp>
         <p:nvSpPr>
-          <p:cNvPr id="22" name="TextBox 21"/>
+          <p:cNvPr id="23" name="TextBox 22"/>
           <p:cNvSpPr txBox="1"/>
           <p:nvPr/>
         </p:nvSpPr>
@@ -24857,7 +27136,7 @@
       </p:sp>
       <p:sp>
         <p:nvSpPr>
-          <p:cNvPr id="23" name="Rounded Rectangle 22"/>
+          <p:cNvPr id="24" name="Rounded Rectangle 23"/>
           <p:cNvSpPr/>
           <p:nvPr/>
         </p:nvSpPr>
@@ -24903,7 +27182,7 @@
       </p:sp>
       <p:sp>
         <p:nvSpPr>
-          <p:cNvPr id="24" name="TextBox 23"/>
+          <p:cNvPr id="25" name="TextBox 24"/>
           <p:cNvSpPr txBox="1"/>
           <p:nvPr/>
         </p:nvSpPr>
@@ -24958,7 +27237,7 @@
       </p:sp>
       <p:sp>
         <p:nvSpPr>
-          <p:cNvPr id="25" name="Rounded Rectangle 24"/>
+          <p:cNvPr id="26" name="Rounded Rectangle 25"/>
           <p:cNvSpPr/>
           <p:nvPr/>
         </p:nvSpPr>
@@ -25004,7 +27283,7 @@
       </p:sp>
       <p:sp>
         <p:nvSpPr>
-          <p:cNvPr id="26" name="TextBox 25"/>
+          <p:cNvPr id="27" name="TextBox 26"/>
           <p:cNvSpPr txBox="1"/>
           <p:nvPr/>
         </p:nvSpPr>
@@ -25059,7 +27338,7 @@
       </p:sp>
       <p:sp>
         <p:nvSpPr>
-          <p:cNvPr id="27" name="Rounded Rectangle 26"/>
+          <p:cNvPr id="28" name="Rounded Rectangle 27"/>
           <p:cNvSpPr/>
           <p:nvPr/>
         </p:nvSpPr>
@@ -25105,7 +27384,7 @@
       </p:sp>
       <p:sp>
         <p:nvSpPr>
-          <p:cNvPr id="28" name="TextBox 27"/>
+          <p:cNvPr id="29" name="TextBox 28"/>
           <p:cNvSpPr txBox="1"/>
           <p:nvPr/>
         </p:nvSpPr>
@@ -25160,7 +27439,7 @@
       </p:sp>
       <p:sp>
         <p:nvSpPr>
-          <p:cNvPr id="29" name="Rounded Rectangle 28"/>
+          <p:cNvPr id="30" name="Rounded Rectangle 29"/>
           <p:cNvSpPr/>
           <p:nvPr/>
         </p:nvSpPr>
@@ -25206,7 +27485,7 @@
       </p:sp>
       <p:sp>
         <p:nvSpPr>
-          <p:cNvPr id="30" name="TextBox 29"/>
+          <p:cNvPr id="31" name="TextBox 30"/>
           <p:cNvSpPr txBox="1"/>
           <p:nvPr/>
         </p:nvSpPr>
@@ -25261,7 +27540,7 @@
       </p:sp>
       <p:sp>
         <p:nvSpPr>
-          <p:cNvPr id="31" name="Rounded Rectangle 30"/>
+          <p:cNvPr id="32" name="Rounded Rectangle 31"/>
           <p:cNvSpPr/>
           <p:nvPr/>
         </p:nvSpPr>
@@ -25307,7 +27586,7 @@
       </p:sp>
       <p:sp>
         <p:nvSpPr>
-          <p:cNvPr id="32" name="TextBox 31"/>
+          <p:cNvPr id="33" name="TextBox 32"/>
           <p:cNvSpPr txBox="1"/>
           <p:nvPr/>
         </p:nvSpPr>
@@ -25362,7 +27641,7 @@
       </p:sp>
       <p:sp>
         <p:nvSpPr>
-          <p:cNvPr id="33" name="Rounded Rectangle 32"/>
+          <p:cNvPr id="34" name="Rounded Rectangle 33"/>
           <p:cNvSpPr/>
           <p:nvPr/>
         </p:nvSpPr>
@@ -25408,7 +27687,7 @@
       </p:sp>
       <p:sp>
         <p:nvSpPr>
-          <p:cNvPr id="34" name="TextBox 33"/>
+          <p:cNvPr id="35" name="TextBox 34"/>
           <p:cNvSpPr txBox="1"/>
           <p:nvPr/>
         </p:nvSpPr>
@@ -25463,7 +27742,7 @@
       </p:sp>
       <p:cxnSp>
         <p:nvCxnSpPr>
-          <p:cNvPr id="35" name="Connector 34"/>
+          <p:cNvPr id="36" name="Connector 35"/>
           <p:cNvCxnSpPr/>
           <p:nvPr/>
         </p:nvCxnSpPr>
@@ -25499,7 +27778,7 @@
       </p:cxnSp>
       <p:cxnSp>
         <p:nvCxnSpPr>
-          <p:cNvPr id="36" name="Connector 35"/>
+          <p:cNvPr id="37" name="Connector 36"/>
           <p:cNvCxnSpPr/>
           <p:nvPr/>
         </p:nvCxnSpPr>
@@ -25535,7 +27814,7 @@
       </p:cxnSp>
       <p:sp>
         <p:nvSpPr>
-          <p:cNvPr id="37" name="Rounded Rectangle 36"/>
+          <p:cNvPr id="38" name="Rounded Rectangle 37"/>
           <p:cNvSpPr/>
           <p:nvPr/>
         </p:nvSpPr>
@@ -25579,7 +27858,7 @@
       </p:sp>
       <p:sp>
         <p:nvSpPr>
-          <p:cNvPr id="38" name="TextBox 37"/>
+          <p:cNvPr id="39" name="TextBox 38"/>
           <p:cNvSpPr txBox="1"/>
           <p:nvPr/>
         </p:nvSpPr>
@@ -25770,7 +28049,7 @@
                 <a:ea typeface="+mn-ea"/>
                 <a:cs typeface="+mn-cs"/>
               </a:rPr>
-              <a:t>15 October 2026</a:t>
+              <a:t>&lt;viva date&gt;</a:t>
             </a:r>
             <a:endParaRPr kumimoji="0" lang="en-US" sz="1200" b="0" i="0" u="none" strike="noStrike" kern="1200" cap="none" spc="0" normalizeH="0" baseline="0" noProof="0" dirty="0">
               <a:ln>
@@ -26888,7 +29167,7 @@
                 <a:ea typeface="+mn-ea"/>
                 <a:cs typeface="+mn-cs"/>
               </a:rPr>
-              <a:t>15 October 2026</a:t>
+              <a:t>&lt;viva date&gt;</a:t>
             </a:r>
             <a:endParaRPr kumimoji="0" lang="en-US" sz="1200" b="0" i="0" u="none" strike="noStrike" kern="1200" cap="none" spc="0" normalizeH="0" baseline="0" noProof="0" dirty="0">
               <a:ln>
@@ -27055,12 +29334,13 @@
                 <a:tableStyleId>{5C22544A-7EE6-4342-B048-85BDC9FD1C3A}</a:tableStyleId>
               </a:tblPr>
               <a:tblGrid>
-                <a:gridCol w="2331720"/>
-                <a:gridCol w="822960"/>
-                <a:gridCol w="822960"/>
-                <a:gridCol w="822960"/>
-                <a:gridCol w="868680"/>
-                <a:gridCol w="914400"/>
+                <a:gridCol w="1920240"/>
+                <a:gridCol w="749808"/>
+                <a:gridCol w="749808"/>
+                <a:gridCol w="749808"/>
+                <a:gridCol w="749808"/>
+                <a:gridCol w="786384"/>
+                <a:gridCol w="877824"/>
               </a:tblGrid>
               <a:tr h="365760">
                 <a:tc>
@@ -27070,7 +29350,7 @@
                     <a:p>
                       <a:pPr algn="l"/>
                       <a:r>
-                        <a:rPr sz="1100" b="1">
+                        <a:rPr sz="1050" b="1">
                           <a:solidFill>
                             <a:srgbClr val="FFFFFF"/>
                           </a:solidFill>
@@ -27093,7 +29373,7 @@
                     <a:p>
                       <a:pPr algn="ctr"/>
                       <a:r>
-                        <a:rPr sz="1100" b="1">
+                        <a:rPr sz="1050" b="1">
                           <a:solidFill>
                             <a:srgbClr val="FFFFFF"/>
                           </a:solidFill>
@@ -27116,7 +29396,7 @@
                     <a:p>
                       <a:pPr algn="ctr"/>
                       <a:r>
-                        <a:rPr sz="1100" b="1">
+                        <a:rPr sz="1050" b="1">
                           <a:solidFill>
                             <a:srgbClr val="FFFFFF"/>
                           </a:solidFill>
@@ -27139,7 +29419,7 @@
                     <a:p>
                       <a:pPr algn="ctr"/>
                       <a:r>
-                        <a:rPr sz="1100" b="1">
+                        <a:rPr sz="1050" b="1">
                           <a:solidFill>
                             <a:srgbClr val="FFFFFF"/>
                           </a:solidFill>
@@ -27162,7 +29442,30 @@
                     <a:p>
                       <a:pPr algn="ctr"/>
                       <a:r>
-                        <a:rPr sz="1100" b="1">
+                        <a:rPr sz="1050" b="1">
+                          <a:solidFill>
+                            <a:srgbClr val="FFFFFF"/>
+                          </a:solidFill>
+                          <a:latin typeface="Arial"/>
+                        </a:rPr>
+                        <a:t>P@500</a:t>
+                      </a:r>
+                    </a:p>
+                  </a:txBody>
+                  <a:tcPr marL="73152" marR="73152" marT="27432" marB="27432" anchor="ctr">
+                    <a:solidFill>
+                      <a:srgbClr val="404040"/>
+                    </a:solidFill>
+                  </a:tcPr>
+                </a:tc>
+                <a:tc>
+                  <a:txBody>
+                    <a:bodyPr wrap="square"/>
+                    <a:lstStyle/>
+                    <a:p>
+                      <a:pPr algn="ctr"/>
+                      <a:r>
+                        <a:rPr sz="1050" b="1">
                           <a:solidFill>
                             <a:srgbClr val="FFFFFF"/>
                           </a:solidFill>
@@ -27185,7 +29488,7 @@
                     <a:p>
                       <a:pPr algn="ctr"/>
                       <a:r>
-                        <a:rPr sz="1100" b="1">
+                        <a:rPr sz="1050" b="1">
                           <a:solidFill>
                             <a:srgbClr val="FFFFFF"/>
                           </a:solidFill>
@@ -27210,7 +29513,7 @@
                     <a:p>
                       <a:pPr algn="l"/>
                       <a:r>
-                        <a:rPr sz="1100" b="0">
+                        <a:rPr sz="1050" b="0">
                           <a:solidFill>
                             <a:srgbClr val="333333"/>
                           </a:solidFill>
@@ -27233,13 +29536,13 @@
                     <a:p>
                       <a:pPr algn="ctr"/>
                       <a:r>
-                        <a:rPr sz="1100" b="0">
+                        <a:rPr sz="1050" b="0">
                           <a:solidFill>
                             <a:srgbClr val="333333"/>
                           </a:solidFill>
                           <a:latin typeface="Arial"/>
                         </a:rPr>
-                        <a:t>0.763</a:t>
+                        <a:t>0.765</a:t>
                       </a:r>
                     </a:p>
                   </a:txBody>
@@ -27256,13 +29559,13 @@
                     <a:p>
                       <a:pPr algn="ctr"/>
                       <a:r>
-                        <a:rPr sz="1100" b="0">
+                        <a:rPr sz="1050" b="0">
                           <a:solidFill>
                             <a:srgbClr val="333333"/>
                           </a:solidFill>
                           <a:latin typeface="Arial"/>
                         </a:rPr>
-                        <a:t>0.016</a:t>
+                        <a:t>0.017</a:t>
                       </a:r>
                     </a:p>
                   </a:txBody>
@@ -27279,7 +29582,7 @@
                     <a:p>
                       <a:pPr algn="ctr"/>
                       <a:r>
-                        <a:rPr sz="1100" b="0">
+                        <a:rPr sz="1050" b="0">
                           <a:solidFill>
                             <a:srgbClr val="333333"/>
                           </a:solidFill>
@@ -27302,13 +29605,13 @@
                     <a:p>
                       <a:pPr algn="ctr"/>
                       <a:r>
-                        <a:rPr sz="1100" b="0">
+                        <a:rPr sz="1050" b="0">
                           <a:solidFill>
                             <a:srgbClr val="333333"/>
                           </a:solidFill>
                           <a:latin typeface="Arial"/>
                         </a:rPr>
-                        <a:t>0.124</a:t>
+                        <a:t>0.038</a:t>
                       </a:r>
                     </a:p>
                   </a:txBody>
@@ -27325,7 +29628,30 @@
                     <a:p>
                       <a:pPr algn="ctr"/>
                       <a:r>
-                        <a:rPr sz="1100" b="0">
+                        <a:rPr sz="1050" b="0">
+                          <a:solidFill>
+                            <a:srgbClr val="333333"/>
+                          </a:solidFill>
+                          <a:latin typeface="Arial"/>
+                        </a:rPr>
+                        <a:t>0.125</a:t>
+                      </a:r>
+                    </a:p>
+                  </a:txBody>
+                  <a:tcPr marL="73152" marR="73152" marT="27432" marB="27432" anchor="ctr">
+                    <a:solidFill>
+                      <a:srgbClr val="FFFFFF"/>
+                    </a:solidFill>
+                  </a:tcPr>
+                </a:tc>
+                <a:tc>
+                  <a:txBody>
+                    <a:bodyPr wrap="square"/>
+                    <a:lstStyle/>
+                    <a:p>
+                      <a:pPr algn="ctr"/>
+                      <a:r>
+                        <a:rPr sz="1050" b="0">
                           <a:solidFill>
                             <a:srgbClr val="333333"/>
                           </a:solidFill>
@@ -27350,7 +29676,7 @@
                     <a:p>
                       <a:pPr algn="l"/>
                       <a:r>
-                        <a:rPr sz="1100" b="0">
+                        <a:rPr sz="1050" b="0">
                           <a:solidFill>
                             <a:srgbClr val="333333"/>
                           </a:solidFill>
@@ -27373,7 +29699,7 @@
                     <a:p>
                       <a:pPr algn="ctr"/>
                       <a:r>
-                        <a:rPr sz="1100" b="0">
+                        <a:rPr sz="1050" b="0">
                           <a:solidFill>
                             <a:srgbClr val="333333"/>
                           </a:solidFill>
@@ -27396,7 +29722,7 @@
                     <a:p>
                       <a:pPr algn="ctr"/>
                       <a:r>
-                        <a:rPr sz="1100" b="0">
+                        <a:rPr sz="1050" b="0">
                           <a:solidFill>
                             <a:srgbClr val="333333"/>
                           </a:solidFill>
@@ -27419,7 +29745,7 @@
                     <a:p>
                       <a:pPr algn="ctr"/>
                       <a:r>
-                        <a:rPr sz="1100" b="0">
+                        <a:rPr sz="1050" b="0">
                           <a:solidFill>
                             <a:srgbClr val="333333"/>
                           </a:solidFill>
@@ -27442,7 +29768,30 @@
                     <a:p>
                       <a:pPr algn="ctr"/>
                       <a:r>
-                        <a:rPr sz="1100" b="0">
+                        <a:rPr sz="1050" b="0">
+                          <a:solidFill>
+                            <a:srgbClr val="333333"/>
+                          </a:solidFill>
+                          <a:latin typeface="Arial"/>
+                        </a:rPr>
+                        <a:t>0.230</a:t>
+                      </a:r>
+                    </a:p>
+                  </a:txBody>
+                  <a:tcPr marL="73152" marR="73152" marT="27432" marB="27432" anchor="ctr">
+                    <a:solidFill>
+                      <a:srgbClr val="F2F2F2"/>
+                    </a:solidFill>
+                  </a:tcPr>
+                </a:tc>
+                <a:tc>
+                  <a:txBody>
+                    <a:bodyPr wrap="square"/>
+                    <a:lstStyle/>
+                    <a:p>
+                      <a:pPr algn="ctr"/>
+                      <a:r>
+                        <a:rPr sz="1050" b="0">
                           <a:solidFill>
                             <a:srgbClr val="333333"/>
                           </a:solidFill>
@@ -27465,7 +29814,7 @@
                     <a:p>
                       <a:pPr algn="ctr"/>
                       <a:r>
-                        <a:rPr sz="1100" b="0">
+                        <a:rPr sz="1050" b="0">
                           <a:solidFill>
                             <a:srgbClr val="333333"/>
                           </a:solidFill>
@@ -27490,7 +29839,7 @@
                     <a:p>
                       <a:pPr algn="l"/>
                       <a:r>
-                        <a:rPr sz="1100" b="1">
+                        <a:rPr sz="1050" b="1">
                           <a:solidFill>
                             <a:srgbClr val="333333"/>
                           </a:solidFill>
@@ -27513,13 +29862,13 @@
                     <a:p>
                       <a:pPr algn="ctr"/>
                       <a:r>
-                        <a:rPr sz="1100" b="1">
+                        <a:rPr sz="1050" b="1">
                           <a:solidFill>
                             <a:srgbClr val="333333"/>
                           </a:solidFill>
                           <a:latin typeface="Arial"/>
                         </a:rPr>
-                        <a:t>0.916</a:t>
+                        <a:t>0.917</a:t>
                       </a:r>
                     </a:p>
                   </a:txBody>
@@ -27536,13 +29885,13 @@
                     <a:p>
                       <a:pPr algn="ctr"/>
                       <a:r>
-                        <a:rPr sz="1100" b="1">
+                        <a:rPr sz="1050" b="1">
                           <a:solidFill>
                             <a:srgbClr val="333333"/>
                           </a:solidFill>
                           <a:latin typeface="Arial"/>
                         </a:rPr>
-                        <a:t>0.215</a:t>
+                        <a:t>0.221</a:t>
                       </a:r>
                     </a:p>
                   </a:txBody>
@@ -27559,7 +29908,7 @@
                     <a:p>
                       <a:pPr algn="ctr"/>
                       <a:r>
-                        <a:rPr sz="1100" b="1">
+                        <a:rPr sz="1050" b="1">
                           <a:solidFill>
                             <a:srgbClr val="333333"/>
                           </a:solidFill>
@@ -27582,13 +29931,13 @@
                     <a:p>
                       <a:pPr algn="ctr"/>
                       <a:r>
-                        <a:rPr sz="1100" b="1">
+                        <a:rPr sz="1050" b="1">
                           <a:solidFill>
                             <a:srgbClr val="333333"/>
                           </a:solidFill>
                           <a:latin typeface="Arial"/>
                         </a:rPr>
-                        <a:t>0.497</a:t>
+                        <a:t>0.154</a:t>
                       </a:r>
                     </a:p>
                   </a:txBody>
@@ -27605,13 +29954,36 @@
                     <a:p>
                       <a:pPr algn="ctr"/>
                       <a:r>
-                        <a:rPr sz="1100" b="1">
+                        <a:rPr sz="1050" b="1">
                           <a:solidFill>
                             <a:srgbClr val="333333"/>
                           </a:solidFill>
                           <a:latin typeface="Arial"/>
                         </a:rPr>
-                        <a:t>24.6%</a:t>
+                        <a:t>0.508</a:t>
+                      </a:r>
+                    </a:p>
+                  </a:txBody>
+                  <a:tcPr marL="73152" marR="73152" marT="27432" marB="27432" anchor="ctr">
+                    <a:solidFill>
+                      <a:srgbClr val="E3F4F1"/>
+                    </a:solidFill>
+                  </a:tcPr>
+                </a:tc>
+                <a:tc>
+                  <a:txBody>
+                    <a:bodyPr wrap="square"/>
+                    <a:lstStyle/>
+                    <a:p>
+                      <a:pPr algn="ctr"/>
+                      <a:r>
+                        <a:rPr sz="1050" b="1">
+                          <a:solidFill>
+                            <a:srgbClr val="333333"/>
+                          </a:solidFill>
+                          <a:latin typeface="Arial"/>
+                        </a:rPr>
+                        <a:t>25.2%</a:t>
                       </a:r>
                     </a:p>
                   </a:txBody>
@@ -27630,7 +30002,7 @@
                     <a:p>
                       <a:pPr algn="l"/>
                       <a:r>
-                        <a:rPr sz="1100" b="0">
+                        <a:rPr sz="1050" b="0">
                           <a:solidFill>
                             <a:srgbClr val="333333"/>
                           </a:solidFill>
@@ -27653,13 +30025,13 @@
                     <a:p>
                       <a:pPr algn="ctr"/>
                       <a:r>
-                        <a:rPr sz="1100" b="0">
+                        <a:rPr sz="1050" b="0">
                           <a:solidFill>
                             <a:srgbClr val="333333"/>
                           </a:solidFill>
                           <a:latin typeface="Arial"/>
                         </a:rPr>
-                        <a:t>0.984</a:t>
+                        <a:t>0.982</a:t>
                       </a:r>
                     </a:p>
                   </a:txBody>
@@ -27676,13 +30048,13 @@
                     <a:p>
                       <a:pPr algn="ctr"/>
                       <a:r>
-                        <a:rPr sz="1100" b="0">
+                        <a:rPr sz="1050" b="0">
                           <a:solidFill>
                             <a:srgbClr val="333333"/>
                           </a:solidFill>
                           <a:latin typeface="Arial"/>
                         </a:rPr>
-                        <a:t>0.549</a:t>
+                        <a:t>0.544</a:t>
                       </a:r>
                     </a:p>
                   </a:txBody>
@@ -27699,7 +30071,7 @@
                     <a:p>
                       <a:pPr algn="ctr"/>
                       <a:r>
-                        <a:rPr sz="1100" b="0">
+                        <a:rPr sz="1050" b="0">
                           <a:solidFill>
                             <a:srgbClr val="333333"/>
                           </a:solidFill>
@@ -27722,7 +30094,30 @@
                     <a:p>
                       <a:pPr algn="ctr"/>
                       <a:r>
-                        <a:rPr sz="1100" b="0">
+                        <a:rPr sz="1050" b="0">
+                          <a:solidFill>
+                            <a:srgbClr val="333333"/>
+                          </a:solidFill>
+                          <a:latin typeface="Arial"/>
+                        </a:rPr>
+                        <a:t>0.284</a:t>
+                      </a:r>
+                    </a:p>
+                  </a:txBody>
+                  <a:tcPr marL="73152" marR="73152" marT="27432" marB="27432" anchor="ctr">
+                    <a:solidFill>
+                      <a:srgbClr val="F2F2F2"/>
+                    </a:solidFill>
+                  </a:tcPr>
+                </a:tc>
+                <a:tc>
+                  <a:txBody>
+                    <a:bodyPr wrap="square"/>
+                    <a:lstStyle/>
+                    <a:p>
+                      <a:pPr algn="ctr"/>
+                      <a:r>
+                        <a:rPr sz="1050" b="0">
                           <a:solidFill>
                             <a:srgbClr val="333333"/>
                           </a:solidFill>
@@ -27745,7 +30140,7 @@
                     <a:p>
                       <a:pPr algn="ctr"/>
                       <a:r>
-                        <a:rPr sz="1100" b="0">
+                        <a:rPr sz="1050" b="0">
                           <a:solidFill>
                             <a:srgbClr val="333333"/>
                           </a:solidFill>
@@ -27770,7 +30165,7 @@
                     <a:p>
                       <a:pPr algn="l"/>
                       <a:r>
-                        <a:rPr sz="1100" b="0">
+                        <a:rPr sz="1050" b="0">
                           <a:solidFill>
                             <a:srgbClr val="333333"/>
                           </a:solidFill>
@@ -27793,13 +30188,13 @@
                     <a:p>
                       <a:pPr algn="ctr"/>
                       <a:r>
-                        <a:rPr sz="1100" b="0">
+                        <a:rPr sz="1050" b="0">
                           <a:solidFill>
                             <a:srgbClr val="333333"/>
                           </a:solidFill>
                           <a:latin typeface="Arial"/>
                         </a:rPr>
-                        <a:t>0.919</a:t>
+                        <a:t>0.920</a:t>
                       </a:r>
                     </a:p>
                   </a:txBody>
@@ -27816,7 +30211,7 @@
                     <a:p>
                       <a:pPr algn="ctr"/>
                       <a:r>
-                        <a:rPr sz="1100" b="0">
+                        <a:rPr sz="1050" b="0">
                           <a:solidFill>
                             <a:srgbClr val="333333"/>
                           </a:solidFill>
@@ -27839,7 +30234,7 @@
                     <a:p>
                       <a:pPr algn="ctr"/>
                       <a:r>
-                        <a:rPr sz="1100" b="0">
+                        <a:rPr sz="1050" b="0">
                           <a:solidFill>
                             <a:srgbClr val="333333"/>
                           </a:solidFill>
@@ -27862,7 +30257,30 @@
                     <a:p>
                       <a:pPr algn="ctr"/>
                       <a:r>
-                        <a:rPr sz="1100" b="0">
+                        <a:rPr sz="1050" b="0">
+                          <a:solidFill>
+                            <a:srgbClr val="333333"/>
+                          </a:solidFill>
+                          <a:latin typeface="Arial"/>
+                        </a:rPr>
+                        <a:t>0.094</a:t>
+                      </a:r>
+                    </a:p>
+                  </a:txBody>
+                  <a:tcPr marL="73152" marR="73152" marT="27432" marB="27432" anchor="ctr">
+                    <a:solidFill>
+                      <a:srgbClr val="FFFFFF"/>
+                    </a:solidFill>
+                  </a:tcPr>
+                </a:tc>
+                <a:tc>
+                  <a:txBody>
+                    <a:bodyPr wrap="square"/>
+                    <a:lstStyle/>
+                    <a:p>
+                      <a:pPr algn="ctr"/>
+                      <a:r>
+                        <a:rPr sz="1050" b="0">
                           <a:solidFill>
                             <a:srgbClr val="333333"/>
                           </a:solidFill>
@@ -27885,13 +30303,13 @@
                     <a:p>
                       <a:pPr algn="ctr"/>
                       <a:r>
-                        <a:rPr sz="1100" b="0">
+                        <a:rPr sz="1050" b="0">
                           <a:solidFill>
                             <a:srgbClr val="333333"/>
                           </a:solidFill>
                           <a:latin typeface="Arial"/>
                         </a:rPr>
-                        <a:t>20.8%</a:t>
+                        <a:t>20.7%</a:t>
                       </a:r>
                     </a:p>
                   </a:txBody>

</xml_diff>

<commit_message>
Rebuild on LightGBM at freeze 2024-01-01
</commit_message>
<xml_diff>
--- a/docs/deck/Cap2_SBOM_Risk_Engine_results.pptx
+++ b/docs/deck/Cap2_SBOM_Risk_Engine_results.pptx
@@ -199,25 +199,25 @@
               <c:strCache>
                 <c:ptCount val="10"/>
                 <c:pt idx="0">
-                  <c:v>Other CWE</c:v>
+                  <c:v>No user interaction</c:v>
                 </c:pt>
                 <c:pt idx="1">
                   <c:v>CWE-79</c:v>
                 </c:pt>
                 <c:pt idx="2">
-                  <c:v>References tagged Exploit</c:v>
+                  <c:v>Other CWE</c:v>
                 </c:pt>
                 <c:pt idx="3">
                   <c:v>Description length</c:v>
                 </c:pt>
                 <c:pt idx="4">
+                  <c:v>Number of references</c:v>
+                </c:pt>
+                <c:pt idx="5">
+                  <c:v>Vendor's historical KEV rate</c:v>
+                </c:pt>
+                <c:pt idx="6">
                   <c:v>GitHub reference</c:v>
-                </c:pt>
-                <c:pt idx="5">
-                  <c:v>Number of references</c:v>
-                </c:pt>
-                <c:pt idx="6">
-                  <c:v>Vendor's historical KEV rate</c:v>
                 </c:pt>
                 <c:pt idx="7">
                   <c:v>Vendor advisories</c:v>
@@ -238,34 +238,34 @@
                 <c:formatCode>General</c:formatCode>
                 <c:ptCount val="10"/>
                 <c:pt idx="0">
-                  <c:v>0.2087</c:v>
+                  <c:v>0.1965</c:v>
                 </c:pt>
                 <c:pt idx="1">
-                  <c:v>0.2125</c:v>
+                  <c:v>0.2251</c:v>
                 </c:pt>
                 <c:pt idx="2">
-                  <c:v>0.2137</c:v>
+                  <c:v>0.2401</c:v>
                 </c:pt>
                 <c:pt idx="3">
-                  <c:v>0.2447</c:v>
+                  <c:v>0.2818</c:v>
                 </c:pt>
                 <c:pt idx="4">
-                  <c:v>0.3288</c:v>
+                  <c:v>0.3381</c:v>
                 </c:pt>
                 <c:pt idx="5">
-                  <c:v>0.3461</c:v>
+                  <c:v>0.3677</c:v>
                 </c:pt>
                 <c:pt idx="6">
-                  <c:v>0.3536</c:v>
+                  <c:v>0.3782</c:v>
                 </c:pt>
                 <c:pt idx="7">
-                  <c:v>0.4238</c:v>
+                  <c:v>0.4087</c:v>
                 </c:pt>
                 <c:pt idx="8">
-                  <c:v>0.5904</c:v>
+                  <c:v>0.5644</c:v>
                 </c:pt>
                 <c:pt idx="9">
-                  <c:v>0.6202</c:v>
+                  <c:v>0.6863</c:v>
                 </c:pt>
               </c:numCache>
             </c:numRef>
@@ -15541,8 +15541,8 @@
         </p:nvSpPr>
         <p:spPr>
           <a:xfrm>
-            <a:off x="457200" y="3200400"/>
-            <a:ext cx="3657600" cy="1691640"/>
+            <a:off x="457200" y="3063240"/>
+            <a:ext cx="3657600" cy="2011680"/>
           </a:xfrm>
           <a:prstGeom prst="rect">
             <a:avLst/>
@@ -15600,6 +15600,38 @@
                 <a:latin typeface="Arial"/>
               </a:rPr>
               <a:t>Removing the ML probability costs +19.2 pp of patch effort (ablation).</a:t>
+            </a:r>
+          </a:p>
+          <a:p>
+            <a:pPr algn="l">
+              <a:spcAft>
+                <a:spcPts val="400"/>
+              </a:spcAft>
+            </a:pPr>
+            <a:r>
+              <a:rPr sz="1000" b="0" i="0">
+                <a:solidFill>
+                  <a:srgbClr val="6B6B6B"/>
+                </a:solidFill>
+                <a:latin typeface="Arial"/>
+              </a:rPr>
+              <a:t>50% / 75% coverage: ours 4% / 15% · CVSS 24% / 44% · EPSS 12% / 43%</a:t>
+            </a:r>
+          </a:p>
+          <a:p>
+            <a:pPr algn="l">
+              <a:spcAft>
+                <a:spcPts val="400"/>
+              </a:spcAft>
+            </a:pPr>
+            <a:r>
+              <a:rPr sz="1000" b="0" i="0">
+                <a:solidFill>
+                  <a:srgbClr val="D63B40"/>
+                </a:solidFill>
+                <a:latin typeface="Arial"/>
+              </a:rPr>
+              <a:t>SBOM case below: constructed validation fixture, not an application. The population case carries the claim.</a:t>
             </a:r>
           </a:p>
         </p:txBody>
@@ -15613,8 +15645,8 @@
           <p:nvPr/>
         </p:nvGraphicFramePr>
         <p:xfrm>
-          <a:off x="457200" y="4937760"/>
-          <a:ext cx="3657600" cy="1371600"/>
+          <a:off x="457200" y="5166360"/>
+          <a:ext cx="3657600" cy="1188720"/>
         </p:xfrm>
         <a:graphic>
           <a:graphicData uri="http://schemas.openxmlformats.org/drawingml/2006/table">
@@ -15628,7 +15660,7 @@
                 <a:gridCol w="777240"/>
                 <a:gridCol w="685800"/>
               </a:tblGrid>
-              <a:tr h="274320">
+              <a:tr h="237744">
                 <a:tc>
                   <a:txBody>
                     <a:bodyPr wrap="square"/>
@@ -15636,13 +15668,13 @@
                     <a:p>
                       <a:pPr algn="l"/>
                       <a:r>
-                        <a:rPr sz="1050" b="1">
+                        <a:rPr sz="950" b="1">
                           <a:solidFill>
                             <a:srgbClr val="FFFFFF"/>
                           </a:solidFill>
                           <a:latin typeface="Arial"/>
                         </a:rPr>
-                        <a:t>kev-app: N=150, M=4</a:t>
+                        <a:t>kev-app (fixture): N=150, M=4</a:t>
                       </a:r>
                     </a:p>
                   </a:txBody>
@@ -15659,7 +15691,7 @@
                     <a:p>
                       <a:pPr algn="ctr"/>
                       <a:r>
-                        <a:rPr sz="1050" b="1">
+                        <a:rPr sz="950" b="1">
                           <a:solidFill>
                             <a:srgbClr val="FFFFFF"/>
                           </a:solidFill>
@@ -15682,7 +15714,7 @@
                     <a:p>
                       <a:pPr algn="ctr"/>
                       <a:r>
-                        <a:rPr sz="1050" b="1">
+                        <a:rPr sz="950" b="1">
                           <a:solidFill>
                             <a:srgbClr val="FFFFFF"/>
                           </a:solidFill>
@@ -15705,7 +15737,7 @@
                     <a:p>
                       <a:pPr algn="ctr"/>
                       <a:r>
-                        <a:rPr sz="1050" b="1">
+                        <a:rPr sz="950" b="1">
                           <a:solidFill>
                             <a:srgbClr val="FFFFFF"/>
                           </a:solidFill>
@@ -15722,7 +15754,7 @@
                   </a:tcPr>
                 </a:tc>
               </a:tr>
-              <a:tr h="274320">
+              <a:tr h="237744">
                 <a:tc>
                   <a:txBody>
                     <a:bodyPr wrap="square"/>
@@ -15730,7 +15762,7 @@
                     <a:p>
                       <a:pPr algn="l"/>
                       <a:r>
-                        <a:rPr sz="1050" b="0">
+                        <a:rPr sz="950" b="0">
                           <a:solidFill>
                             <a:srgbClr val="333333"/>
                           </a:solidFill>
@@ -15753,7 +15785,7 @@
                     <a:p>
                       <a:pPr algn="ctr"/>
                       <a:r>
-                        <a:rPr sz="1050" b="0">
+                        <a:rPr sz="950" b="0">
                           <a:solidFill>
                             <a:srgbClr val="333333"/>
                           </a:solidFill>
@@ -15776,7 +15808,7 @@
                     <a:p>
                       <a:pPr algn="ctr"/>
                       <a:r>
-                        <a:rPr sz="1050" b="0">
+                        <a:rPr sz="950" b="0">
                           <a:solidFill>
                             <a:srgbClr val="333333"/>
                           </a:solidFill>
@@ -15799,7 +15831,7 @@
                     <a:p>
                       <a:pPr algn="ctr"/>
                       <a:r>
-                        <a:rPr sz="1050" b="0">
+                        <a:rPr sz="950" b="0">
                           <a:solidFill>
                             <a:srgbClr val="333333"/>
                           </a:solidFill>
@@ -15816,7 +15848,7 @@
                   </a:tcPr>
                 </a:tc>
               </a:tr>
-              <a:tr h="274320">
+              <a:tr h="237744">
                 <a:tc>
                   <a:txBody>
                     <a:bodyPr wrap="square"/>
@@ -15824,7 +15856,7 @@
                     <a:p>
                       <a:pPr algn="l"/>
                       <a:r>
-                        <a:rPr sz="1050" b="0">
+                        <a:rPr sz="950" b="0">
                           <a:solidFill>
                             <a:srgbClr val="333333"/>
                           </a:solidFill>
@@ -15847,7 +15879,7 @@
                     <a:p>
                       <a:pPr algn="ctr"/>
                       <a:r>
-                        <a:rPr sz="1050" b="0">
+                        <a:rPr sz="950" b="0">
                           <a:solidFill>
                             <a:srgbClr val="333333"/>
                           </a:solidFill>
@@ -15870,7 +15902,7 @@
                     <a:p>
                       <a:pPr algn="ctr"/>
                       <a:r>
-                        <a:rPr sz="1050" b="0">
+                        <a:rPr sz="950" b="0">
                           <a:solidFill>
                             <a:srgbClr val="333333"/>
                           </a:solidFill>
@@ -15893,7 +15925,7 @@
                     <a:p>
                       <a:pPr algn="ctr"/>
                       <a:r>
-                        <a:rPr sz="1050" b="0">
+                        <a:rPr sz="950" b="0">
                           <a:solidFill>
                             <a:srgbClr val="333333"/>
                           </a:solidFill>
@@ -15910,7 +15942,7 @@
                   </a:tcPr>
                 </a:tc>
               </a:tr>
-              <a:tr h="274320">
+              <a:tr h="237744">
                 <a:tc>
                   <a:txBody>
                     <a:bodyPr wrap="square"/>
@@ -15918,7 +15950,7 @@
                     <a:p>
                       <a:pPr algn="l"/>
                       <a:r>
-                        <a:rPr sz="1050" b="1">
+                        <a:rPr sz="950" b="1">
                           <a:solidFill>
                             <a:srgbClr val="333333"/>
                           </a:solidFill>
@@ -15941,7 +15973,7 @@
                     <a:p>
                       <a:pPr algn="ctr"/>
                       <a:r>
-                        <a:rPr sz="1050" b="1">
+                        <a:rPr sz="950" b="1">
                           <a:solidFill>
                             <a:srgbClr val="333333"/>
                           </a:solidFill>
@@ -15964,7 +15996,7 @@
                     <a:p>
                       <a:pPr algn="ctr"/>
                       <a:r>
-                        <a:rPr sz="1050" b="1">
+                        <a:rPr sz="950" b="1">
                           <a:solidFill>
                             <a:srgbClr val="333333"/>
                           </a:solidFill>
@@ -15987,7 +16019,7 @@
                     <a:p>
                       <a:pPr algn="ctr"/>
                       <a:r>
-                        <a:rPr sz="1050" b="1">
+                        <a:rPr sz="950" b="1">
                           <a:solidFill>
                             <a:srgbClr val="333333"/>
                           </a:solidFill>
@@ -16004,7 +16036,7 @@
                   </a:tcPr>
                 </a:tc>
               </a:tr>
-              <a:tr h="274320">
+              <a:tr h="237744">
                 <a:tc>
                   <a:txBody>
                     <a:bodyPr wrap="square"/>
@@ -16012,7 +16044,7 @@
                     <a:p>
                       <a:pPr algn="l"/>
                       <a:r>
-                        <a:rPr sz="1050" b="0">
+                        <a:rPr sz="950" b="0">
                           <a:solidFill>
                             <a:srgbClr val="333333"/>
                           </a:solidFill>
@@ -16035,7 +16067,7 @@
                     <a:p>
                       <a:pPr algn="ctr"/>
                       <a:r>
-                        <a:rPr sz="1050" b="0">
+                        <a:rPr sz="950" b="0">
                           <a:solidFill>
                             <a:srgbClr val="333333"/>
                           </a:solidFill>
@@ -16058,7 +16090,7 @@
                     <a:p>
                       <a:pPr algn="ctr"/>
                       <a:r>
-                        <a:rPr sz="1050" b="0">
+                        <a:rPr sz="950" b="0">
                           <a:solidFill>
                             <a:srgbClr val="333333"/>
                           </a:solidFill>
@@ -16081,7 +16113,7 @@
                     <a:p>
                       <a:pPr algn="ctr"/>
                       <a:r>
-                        <a:rPr sz="1050" b="0">
+                        <a:rPr sz="950" b="0">
                           <a:solidFill>
                             <a:srgbClr val="333333"/>
                           </a:solidFill>
@@ -17798,7 +17830,7 @@
         <p:spPr>
           <a:xfrm>
             <a:off x="457200" y="1325880"/>
-            <a:ext cx="6650587" cy="4800600"/>
+            <a:ext cx="6816852" cy="4800600"/>
           </a:xfrm>
           <a:prstGeom prst="rect">
             <a:avLst/>
@@ -20122,7 +20154,7 @@
                           </a:solidFill>
                           <a:latin typeface="Arial"/>
                         </a:rPr>
-                        <a:t>Model without EPSS: test AUC 0.917 vs CVSS 0.765</a:t>
+                        <a:t>Model without EPSS: test AUC 0.915 vs CVSS 0.765</a:t>
                       </a:r>
                     </a:p>
                   </a:txBody>
@@ -20423,7 +20455,7 @@
                 </a:solidFill>
                 <a:latin typeface="Arial"/>
               </a:rPr>
-              <a:t>Numbers are read from site/model_meta.json and site/backtest.json by scripts/build_deck.py · results snapshot v1.0-cap2-dirty · generated 2026-09-24</a:t>
+              <a:t>Numbers are read from site/model_meta.json and site/backtest.json by scripts/build_deck.py · results snapshot bd13b79-dirty · generated 2026-09-24</a:t>
             </a:r>
           </a:p>
         </p:txBody>
@@ -20802,6 +20834,22 @@
                 <a:latin typeface="Arial"/>
               </a:rPr>
               <a:t>–  Backtest CVSS is today's NVD value; one SBOM yields few later-exploited CVEs (population case added).</a:t>
+            </a:r>
+          </a:p>
+          <a:p>
+            <a:pPr algn="l">
+              <a:spcAft>
+                <a:spcPts val="1000"/>
+              </a:spcAft>
+            </a:pPr>
+            <a:r>
+              <a:rPr sz="1400" b="0" i="0">
+                <a:solidFill>
+                  <a:srgbClr val="333333"/>
+                </a:solidFill>
+                <a:latin typeface="Arial"/>
+              </a:rPr>
+              <a:t>–  The generated backtest fixture is a constructed validation set, not an application: its packages carry the answer-key CVEs and its dependency tree is one level deep.</a:t>
             </a:r>
           </a:p>
           <a:p>
@@ -29868,7 +29916,7 @@
                           </a:solidFill>
                           <a:latin typeface="Arial"/>
                         </a:rPr>
-                        <a:t>0.917</a:t>
+                        <a:t>0.915</a:t>
                       </a:r>
                     </a:p>
                   </a:txBody>
@@ -29891,7 +29939,7 @@
                           </a:solidFill>
                           <a:latin typeface="Arial"/>
                         </a:rPr>
-                        <a:t>0.221</a:t>
+                        <a:t>0.200</a:t>
                       </a:r>
                     </a:p>
                   </a:txBody>
@@ -29914,7 +29962,7 @@
                           </a:solidFill>
                           <a:latin typeface="Arial"/>
                         </a:rPr>
-                        <a:t>0.410</a:t>
+                        <a:t>0.380</a:t>
                       </a:r>
                     </a:p>
                   </a:txBody>
@@ -29937,7 +29985,7 @@
                           </a:solidFill>
                           <a:latin typeface="Arial"/>
                         </a:rPr>
-                        <a:t>0.154</a:t>
+                        <a:t>0.148</a:t>
                       </a:r>
                     </a:p>
                   </a:txBody>
@@ -29960,7 +30008,7 @@
                           </a:solidFill>
                           <a:latin typeface="Arial"/>
                         </a:rPr>
-                        <a:t>0.508</a:t>
+                        <a:t>0.467</a:t>
                       </a:r>
                     </a:p>
                   </a:txBody>
@@ -29983,7 +30031,7 @@
                           </a:solidFill>
                           <a:latin typeface="Arial"/>
                         </a:rPr>
-                        <a:t>25.2%</a:t>
+                        <a:t>25.6%</a:t>
                       </a:r>
                     </a:p>
                   </a:txBody>
@@ -30031,7 +30079,7 @@
                           </a:solidFill>
                           <a:latin typeface="Arial"/>
                         </a:rPr>
-                        <a:t>0.982</a:t>
+                        <a:t>0.983</a:t>
                       </a:r>
                     </a:p>
                   </a:txBody>
@@ -30054,7 +30102,7 @@
                           </a:solidFill>
                           <a:latin typeface="Arial"/>
                         </a:rPr>
-                        <a:t>0.544</a:t>
+                        <a:t>0.548</a:t>
                       </a:r>
                     </a:p>
                   </a:txBody>
@@ -30077,7 +30125,7 @@
                           </a:solidFill>
                           <a:latin typeface="Arial"/>
                         </a:rPr>
-                        <a:t>0.730</a:t>
+                        <a:t>0.720</a:t>
                       </a:r>
                     </a:p>
                   </a:txBody>
@@ -30100,7 +30148,7 @@
                           </a:solidFill>
                           <a:latin typeface="Arial"/>
                         </a:rPr>
-                        <a:t>0.284</a:t>
+                        <a:t>0.286</a:t>
                       </a:r>
                     </a:p>
                   </a:txBody>
@@ -30123,7 +30171,7 @@
                           </a:solidFill>
                           <a:latin typeface="Arial"/>
                         </a:rPr>
-                        <a:t>0.802</a:t>
+                        <a:t>0.807</a:t>
                       </a:r>
                     </a:p>
                   </a:txBody>
@@ -30146,7 +30194,7 @@
                           </a:solidFill>
                           <a:latin typeface="Arial"/>
                         </a:rPr>
-                        <a:t>3.9%</a:t>
+                        <a:t>3.8%</a:t>
                       </a:r>
                     </a:p>
                   </a:txBody>

</xml_diff>

<commit_message>
Deck and report from v1.0-cap2
</commit_message>
<xml_diff>
--- a/docs/deck/Cap2_SBOM_Risk_Engine_results.pptx
+++ b/docs/deck/Cap2_SBOM_Risk_Engine_results.pptx
@@ -14983,7 +14983,7 @@
                 </a:solidFill>
                 <a:cs typeface="Arial" panose="020B0604020202020204" pitchFamily="34" charset="0"/>
               </a:rPr>
-              <a:t>Date: &lt;viva date&gt;</a:t>
+              <a:t>Date: 10th October 2026</a:t>
             </a:r>
             <a:r>
               <a:rPr lang="en-US" sz="1400" baseline="30000" dirty="0">
@@ -15307,7 +15307,7 @@
                 <a:ea typeface="+mn-ea"/>
                 <a:cs typeface="+mn-cs"/>
               </a:rPr>
-              <a:t>&lt;viva date&gt;</a:t>
+              <a:t>10th October 2026</a:t>
             </a:r>
             <a:endParaRPr kumimoji="0" lang="en-US" sz="1200" b="0" i="0" u="none" strike="noStrike" kern="1200" cap="none" spc="0" normalizeH="0" baseline="0" noProof="0" dirty="0">
               <a:ln>
@@ -16274,7 +16274,7 @@
                 <a:ea typeface="+mn-ea"/>
                 <a:cs typeface="+mn-cs"/>
               </a:rPr>
-              <a:t>&lt;viva date&gt;</a:t>
+              <a:t>10th October 2026</a:t>
             </a:r>
             <a:endParaRPr kumimoji="0" lang="en-US" sz="1200" b="0" i="0" u="none" strike="noStrike" kern="1200" cap="none" spc="0" normalizeH="0" baseline="0" noProof="0" dirty="0">
               <a:ln>
@@ -17704,7 +17704,7 @@
                 <a:ea typeface="+mn-ea"/>
                 <a:cs typeface="+mn-cs"/>
               </a:rPr>
-              <a:t>&lt;viva date&gt;</a:t>
+              <a:t>10th October 2026</a:t>
             </a:r>
             <a:endParaRPr kumimoji="0" lang="en-US" sz="1200" b="0" i="0" u="none" strike="noStrike" kern="1200" cap="none" spc="0" normalizeH="0" baseline="0" noProof="0" dirty="0">
               <a:ln>
@@ -18273,7 +18273,7 @@
                 <a:ea typeface="+mn-ea"/>
                 <a:cs typeface="+mn-cs"/>
               </a:rPr>
-              <a:t>&lt;viva date&gt;</a:t>
+              <a:t>10th October 2026</a:t>
             </a:r>
             <a:endParaRPr kumimoji="0" lang="en-US" sz="1200" b="0" i="0" u="none" strike="noStrike" kern="1200" cap="none" spc="0" normalizeH="0" baseline="0" noProof="0" dirty="0">
               <a:ln>
@@ -19903,7 +19903,7 @@
                 <a:ea typeface="+mn-ea"/>
                 <a:cs typeface="+mn-cs"/>
               </a:rPr>
-              <a:t>&lt;viva date&gt;</a:t>
+              <a:t>10th October 2026</a:t>
             </a:r>
             <a:endParaRPr kumimoji="0" lang="en-US" sz="1200" b="0" i="0" u="none" strike="noStrike" kern="1200" cap="none" spc="0" normalizeH="0" baseline="0" noProof="0">
               <a:ln>
@@ -20455,7 +20455,7 @@
                 </a:solidFill>
                 <a:latin typeface="Arial"/>
               </a:rPr>
-              <a:t>Numbers are read from site/model_meta.json and site/backtest.json by scripts/build_deck.py · results snapshot bd13b79-dirty · generated 2026-09-24</a:t>
+              <a:t>Numbers are read from site/model_meta.json and site/backtest.json by scripts/build_deck.py · results snapshot v1.0-cap2 · generated 2026-09-24</a:t>
             </a:r>
           </a:p>
         </p:txBody>
@@ -20582,7 +20582,7 @@
                 <a:ea typeface="+mn-ea"/>
                 <a:cs typeface="+mn-cs"/>
               </a:rPr>
-              <a:t>&lt;viva date&gt;</a:t>
+              <a:t>10th October 2026</a:t>
             </a:r>
             <a:endParaRPr kumimoji="0" lang="en-US" sz="1200" b="0" i="0" u="none" strike="noStrike" kern="1200" cap="none" spc="0" normalizeH="0" baseline="0" noProof="0" dirty="0">
               <a:ln>
@@ -21151,7 +21151,7 @@
                 <a:ea typeface="+mn-ea"/>
                 <a:cs typeface="+mn-cs"/>
               </a:rPr>
-              <a:t>&lt;viva date&gt;</a:t>
+              <a:t>10th October 2026</a:t>
             </a:r>
             <a:endParaRPr kumimoji="0" lang="en-US" sz="1200" b="0" i="0" u="none" strike="noStrike" kern="1200" cap="none" spc="0" normalizeH="0" baseline="0" noProof="0">
               <a:ln>
@@ -21702,7 +21702,7 @@
                 <a:ea typeface="+mn-ea"/>
                 <a:cs typeface="+mn-cs"/>
               </a:rPr>
-              <a:t>&lt;viva date&gt;</a:t>
+              <a:t>10th October 2026</a:t>
             </a:r>
             <a:endParaRPr kumimoji="0" lang="en-US" sz="1200" b="0" i="0" u="none" strike="noStrike" kern="1200" cap="none" spc="0" normalizeH="0" baseline="0" noProof="0">
               <a:ln>
@@ -22994,7 +22994,7 @@
                 <a:ea typeface="+mn-ea"/>
                 <a:cs typeface="+mn-cs"/>
               </a:rPr>
-              <a:t>&lt;viva date&gt;</a:t>
+              <a:t>10th October 2026</a:t>
             </a:r>
             <a:endParaRPr kumimoji="0" lang="en-US" sz="1200" b="0" i="0" u="none" strike="noStrike" kern="1200" cap="none" spc="0" normalizeH="0" baseline="0" noProof="0" dirty="0">
               <a:ln>
@@ -23312,7 +23312,7 @@
                 <a:ea typeface="+mn-ea"/>
                 <a:cs typeface="+mn-cs"/>
               </a:rPr>
-              <a:t>&lt;viva date&gt;</a:t>
+              <a:t>10th October 2026</a:t>
             </a:r>
             <a:endParaRPr kumimoji="0" lang="en-US" sz="1200" b="0" i="0" u="none" strike="noStrike" kern="1200" cap="none" spc="0" normalizeH="0" baseline="0" noProof="0">
               <a:ln>
@@ -25196,7 +25196,7 @@
                 <a:ea typeface="+mn-ea"/>
                 <a:cs typeface="+mn-cs"/>
               </a:rPr>
-              <a:t>&lt;viva date&gt;</a:t>
+              <a:t>10th October 2026</a:t>
             </a:r>
             <a:endParaRPr kumimoji="0" lang="en-US" sz="1200" b="0" i="0" u="none" strike="noStrike" kern="1200" cap="none" spc="0" normalizeH="0" baseline="0" noProof="0">
               <a:ln>
@@ -25557,7 +25557,7 @@
                 <a:ea typeface="+mn-ea"/>
                 <a:cs typeface="+mn-cs"/>
               </a:rPr>
-              <a:t>&lt;viva date&gt;</a:t>
+              <a:t>10th October 2026</a:t>
             </a:r>
             <a:endParaRPr kumimoji="0" lang="en-US" sz="1200" b="0" i="0" u="none" strike="noStrike" kern="1200" cap="none" spc="0" normalizeH="0" baseline="0" noProof="0">
               <a:ln>
@@ -26434,7 +26434,7 @@
                 <a:ea typeface="+mn-ea"/>
                 <a:cs typeface="+mn-cs"/>
               </a:rPr>
-              <a:t>&lt;viva date&gt;</a:t>
+              <a:t>10th October 2026</a:t>
             </a:r>
             <a:endParaRPr kumimoji="0" lang="en-US" sz="1200" b="0" i="0" u="none" strike="noStrike" kern="1200" cap="none" spc="0" normalizeH="0" baseline="0" noProof="0">
               <a:ln>
@@ -28097,7 +28097,7 @@
                 <a:ea typeface="+mn-ea"/>
                 <a:cs typeface="+mn-cs"/>
               </a:rPr>
-              <a:t>&lt;viva date&gt;</a:t>
+              <a:t>10th October 2026</a:t>
             </a:r>
             <a:endParaRPr kumimoji="0" lang="en-US" sz="1200" b="0" i="0" u="none" strike="noStrike" kern="1200" cap="none" spc="0" normalizeH="0" baseline="0" noProof="0" dirty="0">
               <a:ln>
@@ -29215,7 +29215,7 @@
                 <a:ea typeface="+mn-ea"/>
                 <a:cs typeface="+mn-cs"/>
               </a:rPr>
-              <a:t>&lt;viva date&gt;</a:t>
+              <a:t>10th October 2026</a:t>
             </a:r>
             <a:endParaRPr kumimoji="0" lang="en-US" sz="1200" b="0" i="0" u="none" strike="noStrike" kern="1200" cap="none" spc="0" normalizeH="0" baseline="0" noProof="0" dirty="0">
               <a:ln>

</xml_diff>